<commit_message>
V.2: Extra 1 and 2 done. Corrected minor bugs. Extra 3 and 4 in progress. Updated .pptx file with new progress
</commit_message>
<xml_diff>
--- a/LabBook_20_EvaristoNicolas.pptx
+++ b/LabBook_20_EvaristoNicolas.pptx
@@ -156,571 +156,10 @@
 <file path=ppt/revisionInfo.xml><?xml version="1.0" encoding="utf-8"?>
 <p1510:revInfo xmlns:a="http://schemas.openxmlformats.org/drawingml/2006/main" xmlns:r="http://schemas.openxmlformats.org/officeDocument/2006/relationships" xmlns:p1510="http://schemas.microsoft.com/office/powerpoint/2015/10/main">
   <p1510:revLst>
+    <p1510:client id="{065FEF74-6D01-5EFA-4879-61C6783FDD95}" v="173" dt="2026-05-03T11:17:06.138"/>
     <p1510:client id="{9AB94315-64B2-F218-7FC4-1F67AD5A42E9}" v="870" dt="2026-05-02T16:35:24.689"/>
   </p1510:revLst>
 </p1510:revInfo>
-</file>
-
-<file path=ppt/changesInfos/changesInfo1.xml><?xml version="1.0" encoding="utf-8"?>
-<pc:chgInfo xmlns:a="http://schemas.openxmlformats.org/drawingml/2006/main" xmlns:r="http://schemas.openxmlformats.org/officeDocument/2006/relationships" xmlns:ac="http://schemas.microsoft.com/office/drawing/2013/main/command" xmlns:pc="http://schemas.microsoft.com/office/powerpoint/2013/main/command">
-  <pc:docChgLst>
-    <pc:chgData name="Evaristo Nicolas Travel" userId="S::enictra@upv.edu.es::cfa6089c-b5d8-45ba-92be-b9f127c611c1" providerId="AD" clId="Web-{9AB94315-64B2-F218-7FC4-1F67AD5A42E9}"/>
-    <pc:docChg chg="addSld modSld sldOrd">
-      <pc:chgData name="Evaristo Nicolas Travel" userId="S::enictra@upv.edu.es::cfa6089c-b5d8-45ba-92be-b9f127c611c1" providerId="AD" clId="Web-{9AB94315-64B2-F218-7FC4-1F67AD5A42E9}" dt="2026-05-02T16:35:24.392" v="675" actId="20577"/>
-      <pc:docMkLst>
-        <pc:docMk/>
-      </pc:docMkLst>
-      <pc:sldChg chg="addSp modSp">
-        <pc:chgData name="Evaristo Nicolas Travel" userId="S::enictra@upv.edu.es::cfa6089c-b5d8-45ba-92be-b9f127c611c1" providerId="AD" clId="Web-{9AB94315-64B2-F218-7FC4-1F67AD5A42E9}" dt="2026-05-02T16:03:41.469" v="506" actId="14100"/>
-        <pc:sldMkLst>
-          <pc:docMk/>
-          <pc:sldMk cId="3712356003" sldId="291"/>
-        </pc:sldMkLst>
-        <pc:spChg chg="mod">
-          <ac:chgData name="Evaristo Nicolas Travel" userId="S::enictra@upv.edu.es::cfa6089c-b5d8-45ba-92be-b9f127c611c1" providerId="AD" clId="Web-{9AB94315-64B2-F218-7FC4-1F67AD5A42E9}" dt="2026-05-02T16:02:56.922" v="487" actId="20577"/>
-          <ac:spMkLst>
-            <pc:docMk/>
-            <pc:sldMk cId="3712356003" sldId="291"/>
-            <ac:spMk id="2" creationId="{CA5F0FDF-2A95-453B-4ECA-AEB637FF2694}"/>
-          </ac:spMkLst>
-        </pc:spChg>
-        <pc:picChg chg="add mod">
-          <ac:chgData name="Evaristo Nicolas Travel" userId="S::enictra@upv.edu.es::cfa6089c-b5d8-45ba-92be-b9f127c611c1" providerId="AD" clId="Web-{9AB94315-64B2-F218-7FC4-1F67AD5A42E9}" dt="2026-05-02T16:03:41.469" v="506" actId="14100"/>
-          <ac:picMkLst>
-            <pc:docMk/>
-            <pc:sldMk cId="3712356003" sldId="291"/>
-            <ac:picMk id="6" creationId="{6581E837-1498-EA2F-40FC-433D65B52FAE}"/>
-          </ac:picMkLst>
-        </pc:picChg>
-        <pc:picChg chg="add mod">
-          <ac:chgData name="Evaristo Nicolas Travel" userId="S::enictra@upv.edu.es::cfa6089c-b5d8-45ba-92be-b9f127c611c1" providerId="AD" clId="Web-{9AB94315-64B2-F218-7FC4-1F67AD5A42E9}" dt="2026-05-02T16:03:34.454" v="505" actId="1076"/>
-          <ac:picMkLst>
-            <pc:docMk/>
-            <pc:sldMk cId="3712356003" sldId="291"/>
-            <ac:picMk id="7" creationId="{94B9BBB1-B16A-9FAF-F5C7-85D3BD0E7EED}"/>
-          </ac:picMkLst>
-        </pc:picChg>
-      </pc:sldChg>
-      <pc:sldChg chg="modSp">
-        <pc:chgData name="Evaristo Nicolas Travel" userId="S::enictra@upv.edu.es::cfa6089c-b5d8-45ba-92be-b9f127c611c1" providerId="AD" clId="Web-{9AB94315-64B2-F218-7FC4-1F67AD5A42E9}" dt="2026-05-02T16:07:21.356" v="515" actId="1076"/>
-        <pc:sldMkLst>
-          <pc:docMk/>
-          <pc:sldMk cId="1802451501" sldId="293"/>
-        </pc:sldMkLst>
-        <pc:spChg chg="mod">
-          <ac:chgData name="Evaristo Nicolas Travel" userId="S::enictra@upv.edu.es::cfa6089c-b5d8-45ba-92be-b9f127c611c1" providerId="AD" clId="Web-{9AB94315-64B2-F218-7FC4-1F67AD5A42E9}" dt="2026-05-02T16:07:21.356" v="515" actId="1076"/>
-          <ac:spMkLst>
-            <pc:docMk/>
-            <pc:sldMk cId="1802451501" sldId="293"/>
-            <ac:spMk id="2" creationId="{FDE3A197-9508-F9F1-1FEB-FF883D78C151}"/>
-          </ac:spMkLst>
-        </pc:spChg>
-      </pc:sldChg>
-      <pc:sldChg chg="addSp delSp modSp">
-        <pc:chgData name="Evaristo Nicolas Travel" userId="S::enictra@upv.edu.es::cfa6089c-b5d8-45ba-92be-b9f127c611c1" providerId="AD" clId="Web-{9AB94315-64B2-F218-7FC4-1F67AD5A42E9}" dt="2026-05-02T16:14:33.292" v="597" actId="20577"/>
-        <pc:sldMkLst>
-          <pc:docMk/>
-          <pc:sldMk cId="2815679427" sldId="294"/>
-        </pc:sldMkLst>
-        <pc:spChg chg="mod">
-          <ac:chgData name="Evaristo Nicolas Travel" userId="S::enictra@upv.edu.es::cfa6089c-b5d8-45ba-92be-b9f127c611c1" providerId="AD" clId="Web-{9AB94315-64B2-F218-7FC4-1F67AD5A42E9}" dt="2026-05-02T16:14:33.292" v="597" actId="20577"/>
-          <ac:spMkLst>
-            <pc:docMk/>
-            <pc:sldMk cId="2815679427" sldId="294"/>
-            <ac:spMk id="2" creationId="{B5029729-ADF3-3B30-4FF9-83BE1DB82BD7}"/>
-          </ac:spMkLst>
-        </pc:spChg>
-        <pc:spChg chg="del mod">
-          <ac:chgData name="Evaristo Nicolas Travel" userId="S::enictra@upv.edu.es::cfa6089c-b5d8-45ba-92be-b9f127c611c1" providerId="AD" clId="Web-{9AB94315-64B2-F218-7FC4-1F67AD5A42E9}" dt="2026-05-02T16:11:53.676" v="581"/>
-          <ac:spMkLst>
-            <pc:docMk/>
-            <pc:sldMk cId="2815679427" sldId="294"/>
-            <ac:spMk id="8" creationId="{0DA14DBA-172E-DA2C-0573-6A00BF18F4A5}"/>
-          </ac:spMkLst>
-        </pc:spChg>
-        <pc:picChg chg="add mod">
-          <ac:chgData name="Evaristo Nicolas Travel" userId="S::enictra@upv.edu.es::cfa6089c-b5d8-45ba-92be-b9f127c611c1" providerId="AD" clId="Web-{9AB94315-64B2-F218-7FC4-1F67AD5A42E9}" dt="2026-05-02T16:12:00.395" v="586" actId="1076"/>
-          <ac:picMkLst>
-            <pc:docMk/>
-            <pc:sldMk cId="2815679427" sldId="294"/>
-            <ac:picMk id="4" creationId="{2DB642EE-D104-8365-EFF8-B86FF45C622F}"/>
-          </ac:picMkLst>
-        </pc:picChg>
-        <pc:picChg chg="add mod">
-          <ac:chgData name="Evaristo Nicolas Travel" userId="S::enictra@upv.edu.es::cfa6089c-b5d8-45ba-92be-b9f127c611c1" providerId="AD" clId="Web-{9AB94315-64B2-F218-7FC4-1F67AD5A42E9}" dt="2026-05-02T16:11:59.395" v="585" actId="1076"/>
-          <ac:picMkLst>
-            <pc:docMk/>
-            <pc:sldMk cId="2815679427" sldId="294"/>
-            <ac:picMk id="5" creationId="{002BF7E3-24D6-4F7E-E8B5-ABDEF8C0B992}"/>
-          </ac:picMkLst>
-        </pc:picChg>
-      </pc:sldChg>
-      <pc:sldChg chg="addSp delSp modSp">
-        <pc:chgData name="Evaristo Nicolas Travel" userId="S::enictra@upv.edu.es::cfa6089c-b5d8-45ba-92be-b9f127c611c1" providerId="AD" clId="Web-{9AB94315-64B2-F218-7FC4-1F67AD5A42E9}" dt="2026-05-02T16:30:12.305" v="622" actId="20577"/>
-        <pc:sldMkLst>
-          <pc:docMk/>
-          <pc:sldMk cId="2685215753" sldId="299"/>
-        </pc:sldMkLst>
-        <pc:spChg chg="mod">
-          <ac:chgData name="Evaristo Nicolas Travel" userId="S::enictra@upv.edu.es::cfa6089c-b5d8-45ba-92be-b9f127c611c1" providerId="AD" clId="Web-{9AB94315-64B2-F218-7FC4-1F67AD5A42E9}" dt="2026-05-02T16:30:12.305" v="622" actId="20577"/>
-          <ac:spMkLst>
-            <pc:docMk/>
-            <pc:sldMk cId="2685215753" sldId="299"/>
-            <ac:spMk id="2" creationId="{43D7D9E5-DAC3-2BB8-7377-826863CBAD4E}"/>
-          </ac:spMkLst>
-        </pc:spChg>
-        <pc:spChg chg="del mod">
-          <ac:chgData name="Evaristo Nicolas Travel" userId="S::enictra@upv.edu.es::cfa6089c-b5d8-45ba-92be-b9f127c611c1" providerId="AD" clId="Web-{9AB94315-64B2-F218-7FC4-1F67AD5A42E9}" dt="2026-05-02T16:29:14.337" v="602"/>
-          <ac:spMkLst>
-            <pc:docMk/>
-            <pc:sldMk cId="2685215753" sldId="299"/>
-            <ac:spMk id="8" creationId="{643565A9-7DB6-D6EE-152F-2852C8BA7986}"/>
-          </ac:spMkLst>
-        </pc:spChg>
-        <pc:picChg chg="add mod">
-          <ac:chgData name="Evaristo Nicolas Travel" userId="S::enictra@upv.edu.es::cfa6089c-b5d8-45ba-92be-b9f127c611c1" providerId="AD" clId="Web-{9AB94315-64B2-F218-7FC4-1F67AD5A42E9}" dt="2026-05-02T16:29:29.866" v="609" actId="1076"/>
-          <ac:picMkLst>
-            <pc:docMk/>
-            <pc:sldMk cId="2685215753" sldId="299"/>
-            <ac:picMk id="4" creationId="{8B02CB76-36A3-A186-8175-41F427EEE00E}"/>
-          </ac:picMkLst>
-        </pc:picChg>
-      </pc:sldChg>
-      <pc:sldChg chg="addSp delSp modSp">
-        <pc:chgData name="Evaristo Nicolas Travel" userId="S::enictra@upv.edu.es::cfa6089c-b5d8-45ba-92be-b9f127c611c1" providerId="AD" clId="Web-{9AB94315-64B2-F218-7FC4-1F67AD5A42E9}" dt="2026-05-02T16:32:42.670" v="647" actId="1076"/>
-        <pc:sldMkLst>
-          <pc:docMk/>
-          <pc:sldMk cId="1023731220" sldId="300"/>
-        </pc:sldMkLst>
-        <pc:spChg chg="mod">
-          <ac:chgData name="Evaristo Nicolas Travel" userId="S::enictra@upv.edu.es::cfa6089c-b5d8-45ba-92be-b9f127c611c1" providerId="AD" clId="Web-{9AB94315-64B2-F218-7FC4-1F67AD5A42E9}" dt="2026-05-02T16:32:40.170" v="645" actId="20577"/>
-          <ac:spMkLst>
-            <pc:docMk/>
-            <pc:sldMk cId="1023731220" sldId="300"/>
-            <ac:spMk id="2" creationId="{EF5B7948-A25A-9043-7061-DD15A9023924}"/>
-          </ac:spMkLst>
-        </pc:spChg>
-        <pc:spChg chg="del mod">
-          <ac:chgData name="Evaristo Nicolas Travel" userId="S::enictra@upv.edu.es::cfa6089c-b5d8-45ba-92be-b9f127c611c1" providerId="AD" clId="Web-{9AB94315-64B2-F218-7FC4-1F67AD5A42E9}" dt="2026-05-02T16:31:16.573" v="625"/>
-          <ac:spMkLst>
-            <pc:docMk/>
-            <pc:sldMk cId="1023731220" sldId="300"/>
-            <ac:spMk id="8" creationId="{B0CFB20A-64F3-A296-71E8-F4FA17D35314}"/>
-          </ac:spMkLst>
-        </pc:spChg>
-        <pc:picChg chg="add mod">
-          <ac:chgData name="Evaristo Nicolas Travel" userId="S::enictra@upv.edu.es::cfa6089c-b5d8-45ba-92be-b9f127c611c1" providerId="AD" clId="Web-{9AB94315-64B2-F218-7FC4-1F67AD5A42E9}" dt="2026-05-02T16:31:31.543" v="631" actId="1076"/>
-          <ac:picMkLst>
-            <pc:docMk/>
-            <pc:sldMk cId="1023731220" sldId="300"/>
-            <ac:picMk id="4" creationId="{3107D893-B5DF-3FD5-47BF-4D7FE678267B}"/>
-          </ac:picMkLst>
-        </pc:picChg>
-        <pc:picChg chg="add mod">
-          <ac:chgData name="Evaristo Nicolas Travel" userId="S::enictra@upv.edu.es::cfa6089c-b5d8-45ba-92be-b9f127c611c1" providerId="AD" clId="Web-{9AB94315-64B2-F218-7FC4-1F67AD5A42E9}" dt="2026-05-02T16:32:42.670" v="647" actId="1076"/>
-          <ac:picMkLst>
-            <pc:docMk/>
-            <pc:sldMk cId="1023731220" sldId="300"/>
-            <ac:picMk id="5" creationId="{D9E476F5-B05B-96F8-9316-233B8480C15A}"/>
-          </ac:picMkLst>
-        </pc:picChg>
-      </pc:sldChg>
-      <pc:sldChg chg="addSp delSp modSp">
-        <pc:chgData name="Evaristo Nicolas Travel" userId="S::enictra@upv.edu.es::cfa6089c-b5d8-45ba-92be-b9f127c611c1" providerId="AD" clId="Web-{9AB94315-64B2-F218-7FC4-1F67AD5A42E9}" dt="2026-05-02T16:35:24.392" v="675" actId="20577"/>
-        <pc:sldMkLst>
-          <pc:docMk/>
-          <pc:sldMk cId="699864314" sldId="301"/>
-        </pc:sldMkLst>
-        <pc:spChg chg="mod">
-          <ac:chgData name="Evaristo Nicolas Travel" userId="S::enictra@upv.edu.es::cfa6089c-b5d8-45ba-92be-b9f127c611c1" providerId="AD" clId="Web-{9AB94315-64B2-F218-7FC4-1F67AD5A42E9}" dt="2026-05-02T16:35:24.392" v="675" actId="20577"/>
-          <ac:spMkLst>
-            <pc:docMk/>
-            <pc:sldMk cId="699864314" sldId="301"/>
-            <ac:spMk id="2" creationId="{42D73A2E-0E5A-8A39-6B70-F9E94D6DBB70}"/>
-          </ac:spMkLst>
-        </pc:spChg>
-        <pc:spChg chg="del mod">
-          <ac:chgData name="Evaristo Nicolas Travel" userId="S::enictra@upv.edu.es::cfa6089c-b5d8-45ba-92be-b9f127c611c1" providerId="AD" clId="Web-{9AB94315-64B2-F218-7FC4-1F67AD5A42E9}" dt="2026-05-02T16:34:20.736" v="650"/>
-          <ac:spMkLst>
-            <pc:docMk/>
-            <pc:sldMk cId="699864314" sldId="301"/>
-            <ac:spMk id="8" creationId="{C3506757-32B7-9151-DA89-AADDB7F7D093}"/>
-          </ac:spMkLst>
-        </pc:spChg>
-        <pc:picChg chg="add mod">
-          <ac:chgData name="Evaristo Nicolas Travel" userId="S::enictra@upv.edu.es::cfa6089c-b5d8-45ba-92be-b9f127c611c1" providerId="AD" clId="Web-{9AB94315-64B2-F218-7FC4-1F67AD5A42E9}" dt="2026-05-02T16:34:46.595" v="663" actId="1076"/>
-          <ac:picMkLst>
-            <pc:docMk/>
-            <pc:sldMk cId="699864314" sldId="301"/>
-            <ac:picMk id="4" creationId="{39A28F15-0717-3B25-2A78-65087010D89D}"/>
-          </ac:picMkLst>
-        </pc:picChg>
-        <pc:picChg chg="add mod">
-          <ac:chgData name="Evaristo Nicolas Travel" userId="S::enictra@upv.edu.es::cfa6089c-b5d8-45ba-92be-b9f127c611c1" providerId="AD" clId="Web-{9AB94315-64B2-F218-7FC4-1F67AD5A42E9}" dt="2026-05-02T16:34:48.689" v="664" actId="1076"/>
-          <ac:picMkLst>
-            <pc:docMk/>
-            <pc:sldMk cId="699864314" sldId="301"/>
-            <ac:picMk id="5" creationId="{27A312D7-FBEB-3B40-AFFC-C827E91BBCE0}"/>
-          </ac:picMkLst>
-        </pc:picChg>
-      </pc:sldChg>
-      <pc:sldChg chg="addSp modSp">
-        <pc:chgData name="Evaristo Nicolas Travel" userId="S::enictra@upv.edu.es::cfa6089c-b5d8-45ba-92be-b9f127c611c1" providerId="AD" clId="Web-{9AB94315-64B2-F218-7FC4-1F67AD5A42E9}" dt="2026-05-02T15:48:35.516" v="432" actId="20577"/>
-        <pc:sldMkLst>
-          <pc:docMk/>
-          <pc:sldMk cId="3663624071" sldId="302"/>
-        </pc:sldMkLst>
-        <pc:spChg chg="mod">
-          <ac:chgData name="Evaristo Nicolas Travel" userId="S::enictra@upv.edu.es::cfa6089c-b5d8-45ba-92be-b9f127c611c1" providerId="AD" clId="Web-{9AB94315-64B2-F218-7FC4-1F67AD5A42E9}" dt="2026-05-02T15:48:35.516" v="432" actId="20577"/>
-          <ac:spMkLst>
-            <pc:docMk/>
-            <pc:sldMk cId="3663624071" sldId="302"/>
-            <ac:spMk id="2" creationId="{CA5F0FDF-2A95-453B-4ECA-AEB637FF2694}"/>
-          </ac:spMkLst>
-        </pc:spChg>
-        <pc:picChg chg="add mod">
-          <ac:chgData name="Evaristo Nicolas Travel" userId="S::enictra@upv.edu.es::cfa6089c-b5d8-45ba-92be-b9f127c611c1" providerId="AD" clId="Web-{9AB94315-64B2-F218-7FC4-1F67AD5A42E9}" dt="2026-05-02T15:46:34.796" v="385" actId="1076"/>
-          <ac:picMkLst>
-            <pc:docMk/>
-            <pc:sldMk cId="3663624071" sldId="302"/>
-            <ac:picMk id="4" creationId="{C3C63B46-4874-A1A7-8B5D-A66E630E772D}"/>
-          </ac:picMkLst>
-        </pc:picChg>
-      </pc:sldChg>
-      <pc:sldChg chg="addSp delSp modSp">
-        <pc:chgData name="Evaristo Nicolas Travel" userId="S::enictra@upv.edu.es::cfa6089c-b5d8-45ba-92be-b9f127c611c1" providerId="AD" clId="Web-{9AB94315-64B2-F218-7FC4-1F67AD5A42E9}" dt="2026-05-02T15:56:59.429" v="469" actId="20577"/>
-        <pc:sldMkLst>
-          <pc:docMk/>
-          <pc:sldMk cId="1558326841" sldId="303"/>
-        </pc:sldMkLst>
-        <pc:spChg chg="mod">
-          <ac:chgData name="Evaristo Nicolas Travel" userId="S::enictra@upv.edu.es::cfa6089c-b5d8-45ba-92be-b9f127c611c1" providerId="AD" clId="Web-{9AB94315-64B2-F218-7FC4-1F67AD5A42E9}" dt="2026-05-02T15:56:59.429" v="469" actId="20577"/>
-          <ac:spMkLst>
-            <pc:docMk/>
-            <pc:sldMk cId="1558326841" sldId="303"/>
-            <ac:spMk id="2" creationId="{82A62DD6-5488-72A1-9926-0CAEE59089A9}"/>
-          </ac:spMkLst>
-        </pc:spChg>
-        <pc:spChg chg="del mod">
-          <ac:chgData name="Evaristo Nicolas Travel" userId="S::enictra@upv.edu.es::cfa6089c-b5d8-45ba-92be-b9f127c611c1" providerId="AD" clId="Web-{9AB94315-64B2-F218-7FC4-1F67AD5A42E9}" dt="2026-05-02T15:51:01.795" v="441"/>
-          <ac:spMkLst>
-            <pc:docMk/>
-            <pc:sldMk cId="1558326841" sldId="303"/>
-            <ac:spMk id="8" creationId="{1EF5BFDA-8EC1-8C73-A932-F36C4DB93C73}"/>
-          </ac:spMkLst>
-        </pc:spChg>
-        <pc:picChg chg="add mod">
-          <ac:chgData name="Evaristo Nicolas Travel" userId="S::enictra@upv.edu.es::cfa6089c-b5d8-45ba-92be-b9f127c611c1" providerId="AD" clId="Web-{9AB94315-64B2-F218-7FC4-1F67AD5A42E9}" dt="2026-05-02T15:50:56.607" v="437" actId="1076"/>
-          <ac:picMkLst>
-            <pc:docMk/>
-            <pc:sldMk cId="1558326841" sldId="303"/>
-            <ac:picMk id="4" creationId="{26AA8E46-9ACF-16AC-3488-6CA4962E1F11}"/>
-          </ac:picMkLst>
-        </pc:picChg>
-        <pc:picChg chg="add mod">
-          <ac:chgData name="Evaristo Nicolas Travel" userId="S::enictra@upv.edu.es::cfa6089c-b5d8-45ba-92be-b9f127c611c1" providerId="AD" clId="Web-{9AB94315-64B2-F218-7FC4-1F67AD5A42E9}" dt="2026-05-02T15:52:19.068" v="450" actId="1076"/>
-          <ac:picMkLst>
-            <pc:docMk/>
-            <pc:sldMk cId="1558326841" sldId="303"/>
-            <ac:picMk id="5" creationId="{2E4BC672-E73E-1314-8E3F-C73A76F0B1FE}"/>
-          </ac:picMkLst>
-        </pc:picChg>
-      </pc:sldChg>
-      <pc:sldChg chg="addSp delSp modSp add replId">
-        <pc:chgData name="Evaristo Nicolas Travel" userId="S::enictra@upv.edu.es::cfa6089c-b5d8-45ba-92be-b9f127c611c1" providerId="AD" clId="Web-{9AB94315-64B2-F218-7FC4-1F67AD5A42E9}" dt="2026-05-02T15:44:01.950" v="357" actId="1076"/>
-        <pc:sldMkLst>
-          <pc:docMk/>
-          <pc:sldMk cId="743057239" sldId="305"/>
-        </pc:sldMkLst>
-        <pc:spChg chg="del">
-          <ac:chgData name="Evaristo Nicolas Travel" userId="S::enictra@upv.edu.es::cfa6089c-b5d8-45ba-92be-b9f127c611c1" providerId="AD" clId="Web-{9AB94315-64B2-F218-7FC4-1F67AD5A42E9}" dt="2026-05-02T15:20:29.515" v="1"/>
-          <ac:spMkLst>
-            <pc:docMk/>
-            <pc:sldMk cId="743057239" sldId="305"/>
-            <ac:spMk id="2" creationId="{23B1F576-8AF3-1449-A446-9D0CCAD7CAF7}"/>
-          </ac:spMkLst>
-        </pc:spChg>
-        <pc:spChg chg="del mod">
-          <ac:chgData name="Evaristo Nicolas Travel" userId="S::enictra@upv.edu.es::cfa6089c-b5d8-45ba-92be-b9f127c611c1" providerId="AD" clId="Web-{9AB94315-64B2-F218-7FC4-1F67AD5A42E9}" dt="2026-05-02T15:20:32.390" v="3"/>
-          <ac:spMkLst>
-            <pc:docMk/>
-            <pc:sldMk cId="743057239" sldId="305"/>
-            <ac:spMk id="4" creationId="{F96C7A4D-58D3-E517-C410-D07B3D0DFA2D}"/>
-          </ac:spMkLst>
-        </pc:spChg>
-        <pc:spChg chg="add del">
-          <ac:chgData name="Evaristo Nicolas Travel" userId="S::enictra@upv.edu.es::cfa6089c-b5d8-45ba-92be-b9f127c611c1" providerId="AD" clId="Web-{9AB94315-64B2-F218-7FC4-1F67AD5A42E9}" dt="2026-05-02T15:20:40.594" v="5"/>
-          <ac:spMkLst>
-            <pc:docMk/>
-            <pc:sldMk cId="743057239" sldId="305"/>
-            <ac:spMk id="5" creationId="{8C0DE22F-BA6D-5FFD-50FB-EAEEDB702DF2}"/>
-          </ac:spMkLst>
-        </pc:spChg>
-        <pc:spChg chg="add mod">
-          <ac:chgData name="Evaristo Nicolas Travel" userId="S::enictra@upv.edu.es::cfa6089c-b5d8-45ba-92be-b9f127c611c1" providerId="AD" clId="Web-{9AB94315-64B2-F218-7FC4-1F67AD5A42E9}" dt="2026-05-02T15:44:01.950" v="357" actId="1076"/>
-          <ac:spMkLst>
-            <pc:docMk/>
-            <pc:sldMk cId="743057239" sldId="305"/>
-            <ac:spMk id="7" creationId="{54366D71-60D4-3387-A7C2-13C04215DBB9}"/>
-          </ac:spMkLst>
-        </pc:spChg>
-        <pc:spChg chg="add del mod">
-          <ac:chgData name="Evaristo Nicolas Travel" userId="S::enictra@upv.edu.es::cfa6089c-b5d8-45ba-92be-b9f127c611c1" providerId="AD" clId="Web-{9AB94315-64B2-F218-7FC4-1F67AD5A42E9}" dt="2026-05-02T15:39:33.567" v="283"/>
-          <ac:spMkLst>
-            <pc:docMk/>
-            <pc:sldMk cId="743057239" sldId="305"/>
-            <ac:spMk id="10" creationId="{F0933DC1-9BD2-4842-F3A6-B3F5FF98264B}"/>
-          </ac:spMkLst>
-        </pc:spChg>
-        <pc:picChg chg="add mod">
-          <ac:chgData name="Evaristo Nicolas Travel" userId="S::enictra@upv.edu.es::cfa6089c-b5d8-45ba-92be-b9f127c611c1" providerId="AD" clId="Web-{9AB94315-64B2-F218-7FC4-1F67AD5A42E9}" dt="2026-05-02T15:33:11.805" v="147" actId="1076"/>
-          <ac:picMkLst>
-            <pc:docMk/>
-            <pc:sldMk cId="743057239" sldId="305"/>
-            <ac:picMk id="6" creationId="{AAABC1F7-C9C2-29A5-4268-5AE66303A396}"/>
-          </ac:picMkLst>
-        </pc:picChg>
-        <pc:picChg chg="add del mod">
-          <ac:chgData name="Evaristo Nicolas Travel" userId="S::enictra@upv.edu.es::cfa6089c-b5d8-45ba-92be-b9f127c611c1" providerId="AD" clId="Web-{9AB94315-64B2-F218-7FC4-1F67AD5A42E9}" dt="2026-05-02T15:39:33.567" v="285"/>
-          <ac:picMkLst>
-            <pc:docMk/>
-            <pc:sldMk cId="743057239" sldId="305"/>
-            <ac:picMk id="8" creationId="{64349B03-43FF-92DD-F070-65E66A66C926}"/>
-          </ac:picMkLst>
-        </pc:picChg>
-        <pc:picChg chg="add del mod">
-          <ac:chgData name="Evaristo Nicolas Travel" userId="S::enictra@upv.edu.es::cfa6089c-b5d8-45ba-92be-b9f127c611c1" providerId="AD" clId="Web-{9AB94315-64B2-F218-7FC4-1F67AD5A42E9}" dt="2026-05-02T15:39:33.567" v="284"/>
-          <ac:picMkLst>
-            <pc:docMk/>
-            <pc:sldMk cId="743057239" sldId="305"/>
-            <ac:picMk id="9" creationId="{BB081789-7210-412E-8B6B-0BA34EDE89A7}"/>
-          </ac:picMkLst>
-        </pc:picChg>
-      </pc:sldChg>
-      <pc:sldChg chg="addSp modSp add ord replId">
-        <pc:chgData name="Evaristo Nicolas Travel" userId="S::enictra@upv.edu.es::cfa6089c-b5d8-45ba-92be-b9f127c611c1" providerId="AD" clId="Web-{9AB94315-64B2-F218-7FC4-1F67AD5A42E9}" dt="2026-05-02T15:43:21.292" v="350" actId="20577"/>
-        <pc:sldMkLst>
-          <pc:docMk/>
-          <pc:sldMk cId="1648878156" sldId="306"/>
-        </pc:sldMkLst>
-        <pc:spChg chg="add mod">
-          <ac:chgData name="Evaristo Nicolas Travel" userId="S::enictra@upv.edu.es::cfa6089c-b5d8-45ba-92be-b9f127c611c1" providerId="AD" clId="Web-{9AB94315-64B2-F218-7FC4-1F67AD5A42E9}" dt="2026-05-02T15:27:37.638" v="82" actId="1076"/>
-          <ac:spMkLst>
-            <pc:docMk/>
-            <pc:sldMk cId="1648878156" sldId="306"/>
-            <ac:spMk id="4" creationId="{CA2FA457-4BAC-FE14-CBB9-5CBEDE7BFD16}"/>
-          </ac:spMkLst>
-        </pc:spChg>
-        <pc:spChg chg="add mod">
-          <ac:chgData name="Evaristo Nicolas Travel" userId="S::enictra@upv.edu.es::cfa6089c-b5d8-45ba-92be-b9f127c611c1" providerId="AD" clId="Web-{9AB94315-64B2-F218-7FC4-1F67AD5A42E9}" dt="2026-05-02T15:43:21.292" v="350" actId="20577"/>
-          <ac:spMkLst>
-            <pc:docMk/>
-            <pc:sldMk cId="1648878156" sldId="306"/>
-            <ac:spMk id="6" creationId="{72B5191F-8EF7-EBCD-AACC-6FBB8A43CF11}"/>
-          </ac:spMkLst>
-        </pc:spChg>
-        <pc:picChg chg="add mod">
-          <ac:chgData name="Evaristo Nicolas Travel" userId="S::enictra@upv.edu.es::cfa6089c-b5d8-45ba-92be-b9f127c611c1" providerId="AD" clId="Web-{9AB94315-64B2-F218-7FC4-1F67AD5A42E9}" dt="2026-05-02T15:24:34.634" v="13" actId="1076"/>
-          <ac:picMkLst>
-            <pc:docMk/>
-            <pc:sldMk cId="1648878156" sldId="306"/>
-            <ac:picMk id="2" creationId="{1FD789FB-9CB7-8877-C3E4-DB9C9B31CF05}"/>
-          </ac:picMkLst>
-        </pc:picChg>
-        <pc:cxnChg chg="add mod">
-          <ac:chgData name="Evaristo Nicolas Travel" userId="S::enictra@upv.edu.es::cfa6089c-b5d8-45ba-92be-b9f127c611c1" providerId="AD" clId="Web-{9AB94315-64B2-F218-7FC4-1F67AD5A42E9}" dt="2026-05-02T15:27:55.232" v="84"/>
-          <ac:cxnSpMkLst>
-            <pc:docMk/>
-            <pc:sldMk cId="1648878156" sldId="306"/>
-            <ac:cxnSpMk id="5" creationId="{A0C104B9-8CC1-FDC0-A01E-B9783B4D5FF0}"/>
-          </ac:cxnSpMkLst>
-        </pc:cxnChg>
-      </pc:sldChg>
-      <pc:sldChg chg="addSp delSp modSp add replId">
-        <pc:chgData name="Evaristo Nicolas Travel" userId="S::enictra@upv.edu.es::cfa6089c-b5d8-45ba-92be-b9f127c611c1" providerId="AD" clId="Web-{9AB94315-64B2-F218-7FC4-1F67AD5A42E9}" dt="2026-05-02T15:45:03.966" v="376" actId="20577"/>
-        <pc:sldMkLst>
-          <pc:docMk/>
-          <pc:sldMk cId="1600955840" sldId="307"/>
-        </pc:sldMkLst>
-        <pc:spChg chg="add mod">
-          <ac:chgData name="Evaristo Nicolas Travel" userId="S::enictra@upv.edu.es::cfa6089c-b5d8-45ba-92be-b9f127c611c1" providerId="AD" clId="Web-{9AB94315-64B2-F218-7FC4-1F67AD5A42E9}" dt="2026-05-02T15:40:45.101" v="320" actId="1076"/>
-          <ac:spMkLst>
-            <pc:docMk/>
-            <pc:sldMk cId="1600955840" sldId="307"/>
-            <ac:spMk id="5" creationId="{20342568-3B9D-DE4D-8BE1-A6B931F9FC10}"/>
-          </ac:spMkLst>
-        </pc:spChg>
-        <pc:spChg chg="del">
-          <ac:chgData name="Evaristo Nicolas Travel" userId="S::enictra@upv.edu.es::cfa6089c-b5d8-45ba-92be-b9f127c611c1" providerId="AD" clId="Web-{9AB94315-64B2-F218-7FC4-1F67AD5A42E9}" dt="2026-05-02T15:34:30.486" v="180"/>
-          <ac:spMkLst>
-            <pc:docMk/>
-            <pc:sldMk cId="1600955840" sldId="307"/>
-            <ac:spMk id="7" creationId="{8D7F8E7F-78B7-5C14-8A74-666A50A54FE7}"/>
-          </ac:spMkLst>
-        </pc:spChg>
-        <pc:spChg chg="del">
-          <ac:chgData name="Evaristo Nicolas Travel" userId="S::enictra@upv.edu.es::cfa6089c-b5d8-45ba-92be-b9f127c611c1" providerId="AD" clId="Web-{9AB94315-64B2-F218-7FC4-1F67AD5A42E9}" dt="2026-05-02T15:34:30.486" v="177"/>
-          <ac:spMkLst>
-            <pc:docMk/>
-            <pc:sldMk cId="1600955840" sldId="307"/>
-            <ac:spMk id="10" creationId="{2E5B24FA-2D87-F249-89AC-27DEA9BD311F}"/>
-          </ac:spMkLst>
-        </pc:spChg>
-        <pc:spChg chg="add mod">
-          <ac:chgData name="Evaristo Nicolas Travel" userId="S::enictra@upv.edu.es::cfa6089c-b5d8-45ba-92be-b9f127c611c1" providerId="AD" clId="Web-{9AB94315-64B2-F218-7FC4-1F67AD5A42E9}" dt="2026-05-02T15:45:03.966" v="376" actId="20577"/>
-          <ac:spMkLst>
-            <pc:docMk/>
-            <pc:sldMk cId="1600955840" sldId="307"/>
-            <ac:spMk id="12" creationId="{851BC1DF-EFCD-D48E-17B8-5E8E9BA619C8}"/>
-          </ac:spMkLst>
-        </pc:spChg>
-        <pc:spChg chg="add mod">
-          <ac:chgData name="Evaristo Nicolas Travel" userId="S::enictra@upv.edu.es::cfa6089c-b5d8-45ba-92be-b9f127c611c1" providerId="AD" clId="Web-{9AB94315-64B2-F218-7FC4-1F67AD5A42E9}" dt="2026-05-02T15:39:49.833" v="290" actId="1076"/>
-          <ac:spMkLst>
-            <pc:docMk/>
-            <pc:sldMk cId="1600955840" sldId="307"/>
-            <ac:spMk id="20" creationId="{759DAA07-9399-1AA9-9ABF-A98F588004A3}"/>
-          </ac:spMkLst>
-        </pc:spChg>
-        <pc:picChg chg="add mod">
-          <ac:chgData name="Evaristo Nicolas Travel" userId="S::enictra@upv.edu.es::cfa6089c-b5d8-45ba-92be-b9f127c611c1" providerId="AD" clId="Web-{9AB94315-64B2-F218-7FC4-1F67AD5A42E9}" dt="2026-05-02T15:41:26.915" v="333" actId="1076"/>
-          <ac:picMkLst>
-            <pc:docMk/>
-            <pc:sldMk cId="1600955840" sldId="307"/>
-            <ac:picMk id="2" creationId="{84B9E66E-DF66-D1DE-7096-7429645CCE40}"/>
-          </ac:picMkLst>
-        </pc:picChg>
-        <pc:picChg chg="add mod">
-          <ac:chgData name="Evaristo Nicolas Travel" userId="S::enictra@upv.edu.es::cfa6089c-b5d8-45ba-92be-b9f127c611c1" providerId="AD" clId="Web-{9AB94315-64B2-F218-7FC4-1F67AD5A42E9}" dt="2026-05-02T15:41:33.915" v="335" actId="1076"/>
-          <ac:picMkLst>
-            <pc:docMk/>
-            <pc:sldMk cId="1600955840" sldId="307"/>
-            <ac:picMk id="4" creationId="{B8ACFE3B-ED01-FBBC-AD2B-C80102CD5133}"/>
-          </ac:picMkLst>
-        </pc:picChg>
-        <pc:picChg chg="del">
-          <ac:chgData name="Evaristo Nicolas Travel" userId="S::enictra@upv.edu.es::cfa6089c-b5d8-45ba-92be-b9f127c611c1" providerId="AD" clId="Web-{9AB94315-64B2-F218-7FC4-1F67AD5A42E9}" dt="2026-05-02T15:34:30.486" v="181"/>
-          <ac:picMkLst>
-            <pc:docMk/>
-            <pc:sldMk cId="1600955840" sldId="307"/>
-            <ac:picMk id="6" creationId="{52FA4790-FEF7-33A3-D291-6B78FBCC3ADC}"/>
-          </ac:picMkLst>
-        </pc:picChg>
-        <pc:picChg chg="del">
-          <ac:chgData name="Evaristo Nicolas Travel" userId="S::enictra@upv.edu.es::cfa6089c-b5d8-45ba-92be-b9f127c611c1" providerId="AD" clId="Web-{9AB94315-64B2-F218-7FC4-1F67AD5A42E9}" dt="2026-05-02T15:34:30.486" v="179"/>
-          <ac:picMkLst>
-            <pc:docMk/>
-            <pc:sldMk cId="1600955840" sldId="307"/>
-            <ac:picMk id="8" creationId="{BA56FA4E-6C3C-DD6A-897E-D2DAA6A352CF}"/>
-          </ac:picMkLst>
-        </pc:picChg>
-        <pc:picChg chg="del">
-          <ac:chgData name="Evaristo Nicolas Travel" userId="S::enictra@upv.edu.es::cfa6089c-b5d8-45ba-92be-b9f127c611c1" providerId="AD" clId="Web-{9AB94315-64B2-F218-7FC4-1F67AD5A42E9}" dt="2026-05-02T15:34:30.486" v="178"/>
-          <ac:picMkLst>
-            <pc:docMk/>
-            <pc:sldMk cId="1600955840" sldId="307"/>
-            <ac:picMk id="9" creationId="{C65D9D7C-D38C-85F1-ECB2-50838FB30435}"/>
-          </ac:picMkLst>
-        </pc:picChg>
-        <pc:picChg chg="add mod">
-          <ac:chgData name="Evaristo Nicolas Travel" userId="S::enictra@upv.edu.es::cfa6089c-b5d8-45ba-92be-b9f127c611c1" providerId="AD" clId="Web-{9AB94315-64B2-F218-7FC4-1F67AD5A42E9}" dt="2026-05-02T15:44:13.090" v="358" actId="1076"/>
-          <ac:picMkLst>
-            <pc:docMk/>
-            <pc:sldMk cId="1600955840" sldId="307"/>
-            <ac:picMk id="11" creationId="{C2909360-301E-97DE-8C59-5E827AC7010C}"/>
-          </ac:picMkLst>
-        </pc:picChg>
-        <pc:picChg chg="add del mod">
-          <ac:chgData name="Evaristo Nicolas Travel" userId="S::enictra@upv.edu.es::cfa6089c-b5d8-45ba-92be-b9f127c611c1" providerId="AD" clId="Web-{9AB94315-64B2-F218-7FC4-1F67AD5A42E9}" dt="2026-05-02T15:38:42.956" v="262"/>
-          <ac:picMkLst>
-            <pc:docMk/>
-            <pc:sldMk cId="1600955840" sldId="307"/>
-            <ac:picMk id="13" creationId="{40BA7A69-E58F-1E91-88A8-0C20DD33FBD8}"/>
-          </ac:picMkLst>
-        </pc:picChg>
-        <pc:picChg chg="add mod">
-          <ac:chgData name="Evaristo Nicolas Travel" userId="S::enictra@upv.edu.es::cfa6089c-b5d8-45ba-92be-b9f127c611c1" providerId="AD" clId="Web-{9AB94315-64B2-F218-7FC4-1F67AD5A42E9}" dt="2026-05-02T15:39:49.802" v="288" actId="1076"/>
-          <ac:picMkLst>
-            <pc:docMk/>
-            <pc:sldMk cId="1600955840" sldId="307"/>
-            <ac:picMk id="15" creationId="{94A19149-F8CE-A080-7262-8781B862918A}"/>
-          </ac:picMkLst>
-        </pc:picChg>
-        <pc:picChg chg="add mod">
-          <ac:chgData name="Evaristo Nicolas Travel" userId="S::enictra@upv.edu.es::cfa6089c-b5d8-45ba-92be-b9f127c611c1" providerId="AD" clId="Web-{9AB94315-64B2-F218-7FC4-1F67AD5A42E9}" dt="2026-05-02T15:39:49.818" v="289" actId="1076"/>
-          <ac:picMkLst>
-            <pc:docMk/>
-            <pc:sldMk cId="1600955840" sldId="307"/>
-            <ac:picMk id="18" creationId="{7E551E54-9FA2-8221-BE8B-D7593E1FCE64}"/>
-          </ac:picMkLst>
-        </pc:picChg>
-        <pc:cxnChg chg="add mod">
-          <ac:chgData name="Evaristo Nicolas Travel" userId="S::enictra@upv.edu.es::cfa6089c-b5d8-45ba-92be-b9f127c611c1" providerId="AD" clId="Web-{9AB94315-64B2-F218-7FC4-1F67AD5A42E9}" dt="2026-05-02T15:41:03.586" v="326"/>
-          <ac:cxnSpMkLst>
-            <pc:docMk/>
-            <pc:sldMk cId="1600955840" sldId="307"/>
-            <ac:cxnSpMk id="21" creationId="{AE68B340-F36C-5C07-BB86-8CE48D45B896}"/>
-          </ac:cxnSpMkLst>
-        </pc:cxnChg>
-      </pc:sldChg>
-      <pc:sldChg chg="addSp delSp modSp add replId">
-        <pc:chgData name="Evaristo Nicolas Travel" userId="S::enictra@upv.edu.es::cfa6089c-b5d8-45ba-92be-b9f127c611c1" providerId="AD" clId="Web-{9AB94315-64B2-F218-7FC4-1F67AD5A42E9}" dt="2026-05-02T16:10:29.233" v="567" actId="1076"/>
-        <pc:sldMkLst>
-          <pc:docMk/>
-          <pc:sldMk cId="1072018827" sldId="308"/>
-        </pc:sldMkLst>
-        <pc:spChg chg="del">
-          <ac:chgData name="Evaristo Nicolas Travel" userId="S::enictra@upv.edu.es::cfa6089c-b5d8-45ba-92be-b9f127c611c1" providerId="AD" clId="Web-{9AB94315-64B2-F218-7FC4-1F67AD5A42E9}" dt="2026-05-02T16:07:38.530" v="517"/>
-          <ac:spMkLst>
-            <pc:docMk/>
-            <pc:sldMk cId="1072018827" sldId="308"/>
-            <ac:spMk id="2" creationId="{F2CC7997-FEE1-8167-BF55-ED47D745E83B}"/>
-          </ac:spMkLst>
-        </pc:spChg>
-        <pc:spChg chg="del">
-          <ac:chgData name="Evaristo Nicolas Travel" userId="S::enictra@upv.edu.es::cfa6089c-b5d8-45ba-92be-b9f127c611c1" providerId="AD" clId="Web-{9AB94315-64B2-F218-7FC4-1F67AD5A42E9}" dt="2026-05-02T16:07:38.530" v="518"/>
-          <ac:spMkLst>
-            <pc:docMk/>
-            <pc:sldMk cId="1072018827" sldId="308"/>
-            <ac:spMk id="4" creationId="{7FA3D177-D188-DB0F-9461-2555106843DA}"/>
-          </ac:spMkLst>
-        </pc:spChg>
-        <pc:picChg chg="add mod">
-          <ac:chgData name="Evaristo Nicolas Travel" userId="S::enictra@upv.edu.es::cfa6089c-b5d8-45ba-92be-b9f127c611c1" providerId="AD" clId="Web-{9AB94315-64B2-F218-7FC4-1F67AD5A42E9}" dt="2026-05-02T16:10:19.858" v="563" actId="1076"/>
-          <ac:picMkLst>
-            <pc:docMk/>
-            <pc:sldMk cId="1072018827" sldId="308"/>
-            <ac:picMk id="5" creationId="{02857F7C-F798-2B65-6313-E74F147493BD}"/>
-          </ac:picMkLst>
-        </pc:picChg>
-        <pc:picChg chg="add mod">
-          <ac:chgData name="Evaristo Nicolas Travel" userId="S::enictra@upv.edu.es::cfa6089c-b5d8-45ba-92be-b9f127c611c1" providerId="AD" clId="Web-{9AB94315-64B2-F218-7FC4-1F67AD5A42E9}" dt="2026-05-02T16:10:28.014" v="566" actId="1076"/>
-          <ac:picMkLst>
-            <pc:docMk/>
-            <pc:sldMk cId="1072018827" sldId="308"/>
-            <ac:picMk id="6" creationId="{5EFA86D3-8737-0D71-F04B-17DAA06A2063}"/>
-          </ac:picMkLst>
-        </pc:picChg>
-        <pc:picChg chg="add mod">
-          <ac:chgData name="Evaristo Nicolas Travel" userId="S::enictra@upv.edu.es::cfa6089c-b5d8-45ba-92be-b9f127c611c1" providerId="AD" clId="Web-{9AB94315-64B2-F218-7FC4-1F67AD5A42E9}" dt="2026-05-02T16:10:25.874" v="565" actId="1076"/>
-          <ac:picMkLst>
-            <pc:docMk/>
-            <pc:sldMk cId="1072018827" sldId="308"/>
-            <ac:picMk id="7" creationId="{2C36E8AA-F381-030F-A8BD-7D625D282555}"/>
-          </ac:picMkLst>
-        </pc:picChg>
-        <pc:picChg chg="add mod">
-          <ac:chgData name="Evaristo Nicolas Travel" userId="S::enictra@upv.edu.es::cfa6089c-b5d8-45ba-92be-b9f127c611c1" providerId="AD" clId="Web-{9AB94315-64B2-F218-7FC4-1F67AD5A42E9}" dt="2026-05-02T16:10:29.233" v="567" actId="1076"/>
-          <ac:picMkLst>
-            <pc:docMk/>
-            <pc:sldMk cId="1072018827" sldId="308"/>
-            <ac:picMk id="8" creationId="{6B012DAA-9CE5-90D1-FD89-FC8C6D3281F8}"/>
-          </ac:picMkLst>
-        </pc:picChg>
-      </pc:sldChg>
-    </pc:docChg>
-  </pc:docChgLst>
-</pc:chgInfo>
 </file>
 
 <file path=ppt/handoutMasters/handoutMaster1.xml><?xml version="1.0" encoding="utf-8"?>
@@ -817,7 +256,7 @@
           <a:p>
             <a:fld id="{8438F8DC-35B0-48E6-A86E-42F1F08DD00F}" type="datetimeFigureOut">
               <a:rPr lang="es-ES" smtClean="0"/>
-              <a:t>02/05/2026</a:t>
+              <a:t>03/05/2026</a:t>
             </a:fld>
             <a:endParaRPr lang="es-ES"/>
           </a:p>
@@ -994,7 +433,7 @@
           <a:p>
             <a:fld id="{FACBDC12-F39B-4B97-8F4D-6734F9D366FF}" type="datetimeFigureOut">
               <a:rPr lang="es-ES" smtClean="0"/>
-              <a:t>02/05/2026</a:t>
+              <a:t>03/05/2026</a:t>
             </a:fld>
             <a:endParaRPr lang="es-ES"/>
           </a:p>
@@ -1434,7 +873,7 @@
           <a:p>
             <a:fld id="{676223B9-C868-4436-87D9-1A3152E1157A}" type="slidenum">
               <a:rPr lang="es-ES" smtClean="0"/>
-              <a:t>10</a:t>
+              <a:t>14</a:t>
             </a:fld>
             <a:endParaRPr lang="es-ES"/>
           </a:p>
@@ -1542,7 +981,7 @@
           <a:p>
             <a:fld id="{676223B9-C868-4436-87D9-1A3152E1157A}" type="slidenum">
               <a:rPr lang="es-ES" smtClean="0"/>
-              <a:t>11</a:t>
+              <a:t>15</a:t>
             </a:fld>
             <a:endParaRPr lang="es-ES"/>
           </a:p>
@@ -1650,7 +1089,7 @@
           <a:p>
             <a:fld id="{676223B9-C868-4436-87D9-1A3152E1157A}" type="slidenum">
               <a:rPr lang="es-ES" smtClean="0"/>
-              <a:t>12</a:t>
+              <a:t>16</a:t>
             </a:fld>
             <a:endParaRPr lang="es-ES"/>
           </a:p>
@@ -1758,7 +1197,7 @@
           <a:p>
             <a:fld id="{676223B9-C868-4436-87D9-1A3152E1157A}" type="slidenum">
               <a:rPr lang="es-ES" smtClean="0"/>
-              <a:t>13</a:t>
+              <a:t>17</a:t>
             </a:fld>
             <a:endParaRPr lang="es-ES"/>
           </a:p>
@@ -1842,7 +1281,7 @@
           <a:p>
             <a:fld id="{676223B9-C868-4436-87D9-1A3152E1157A}" type="slidenum">
               <a:rPr lang="es-ES" smtClean="0"/>
-              <a:t>14</a:t>
+              <a:t>18</a:t>
             </a:fld>
             <a:endParaRPr lang="es-ES"/>
           </a:p>
@@ -1950,7 +1389,7 @@
           <a:p>
             <a:fld id="{676223B9-C868-4436-87D9-1A3152E1157A}" type="slidenum">
               <a:rPr lang="es-ES" smtClean="0"/>
-              <a:t>15</a:t>
+              <a:t>19</a:t>
             </a:fld>
             <a:endParaRPr lang="es-ES"/>
           </a:p>
@@ -2058,7 +1497,7 @@
           <a:p>
             <a:fld id="{676223B9-C868-4436-87D9-1A3152E1157A}" type="slidenum">
               <a:rPr lang="es-ES" smtClean="0"/>
-              <a:t>16</a:t>
+              <a:t>20</a:t>
             </a:fld>
             <a:endParaRPr lang="es-ES"/>
           </a:p>
@@ -2166,7 +1605,7 @@
           <a:p>
             <a:fld id="{676223B9-C868-4436-87D9-1A3152E1157A}" type="slidenum">
               <a:rPr lang="es-ES" smtClean="0"/>
-              <a:t>17</a:t>
+              <a:t>21</a:t>
             </a:fld>
             <a:endParaRPr lang="es-ES"/>
           </a:p>
@@ -2274,7 +1713,7 @@
           <a:p>
             <a:fld id="{676223B9-C868-4436-87D9-1A3152E1157A}" type="slidenum">
               <a:rPr lang="es-ES" smtClean="0"/>
-              <a:t>6</a:t>
+              <a:t>5</a:t>
             </a:fld>
             <a:endParaRPr lang="es-ES"/>
           </a:p>
@@ -2382,7 +1821,7 @@
           <a:p>
             <a:fld id="{676223B9-C868-4436-87D9-1A3152E1157A}" type="slidenum">
               <a:rPr lang="es-ES" smtClean="0"/>
-              <a:t>5</a:t>
+              <a:t>6</a:t>
             </a:fld>
             <a:endParaRPr lang="es-ES"/>
           </a:p>
@@ -2598,7 +2037,7 @@
           <a:p>
             <a:fld id="{676223B9-C868-4436-87D9-1A3152E1157A}" type="slidenum">
               <a:rPr lang="es-ES" smtClean="0"/>
-              <a:t>5</a:t>
+              <a:t>8</a:t>
             </a:fld>
             <a:endParaRPr lang="es-ES"/>
           </a:p>
@@ -2706,7 +2145,7 @@
           <a:p>
             <a:fld id="{676223B9-C868-4436-87D9-1A3152E1157A}" type="slidenum">
               <a:rPr lang="es-ES" smtClean="0"/>
-              <a:t>6</a:t>
+              <a:t>9</a:t>
             </a:fld>
             <a:endParaRPr lang="es-ES"/>
           </a:p>
@@ -2814,7 +2253,7 @@
           <a:p>
             <a:fld id="{676223B9-C868-4436-87D9-1A3152E1157A}" type="slidenum">
               <a:rPr lang="es-ES" smtClean="0"/>
-              <a:t>7</a:t>
+              <a:t>10</a:t>
             </a:fld>
             <a:endParaRPr lang="es-ES"/>
           </a:p>
@@ -2922,7 +2361,7 @@
           <a:p>
             <a:fld id="{676223B9-C868-4436-87D9-1A3152E1157A}" type="slidenum">
               <a:rPr lang="es-ES" smtClean="0"/>
-              <a:t>9</a:t>
+              <a:t>12</a:t>
             </a:fld>
             <a:endParaRPr lang="es-ES"/>
           </a:p>
@@ -4541,32 +3980,29 @@
           </a:prstGeom>
         </p:spPr>
         <p:txBody>
-          <a:bodyPr vert="horz" wrap="square" lIns="0" tIns="12700" rIns="0" bIns="0" rtlCol="0">
+          <a:bodyPr vert="horz" wrap="square" lIns="0" tIns="12700" rIns="0" bIns="0" rtlCol="0" anchor="t">
             <a:spAutoFit/>
           </a:bodyPr>
           <a:lstStyle/>
           <a:p>
             <a:pPr marL="12700">
-              <a:lnSpc>
-                <a:spcPct val="100000"/>
-              </a:lnSpc>
               <a:spcBef>
                 <a:spcPts val="100"/>
               </a:spcBef>
             </a:pPr>
             <a:r>
-              <a:rPr lang="es-ES" spc="165" dirty="0" err="1">
+              <a:rPr lang="es-ES" spc="165" err="1">
                 <a:latin typeface="Arial"/>
                 <a:cs typeface="Arial"/>
               </a:rPr>
               <a:t>Student</a:t>
             </a:r>
             <a:r>
-              <a:rPr lang="es-ES" spc="165" dirty="0">
+              <a:rPr lang="es-ES" spc="165">
                 <a:latin typeface="Arial"/>
                 <a:cs typeface="Arial"/>
               </a:rPr>
-              <a:t>: </a:t>
+              <a:t>: Evaristo Nicolas Travel</a:t>
             </a:r>
             <a:endParaRPr sz="1800" dirty="0">
               <a:latin typeface="Arial"/>
@@ -4954,7 +4390,7 @@
                 <a:ea typeface="+mn-lt"/>
                 <a:cs typeface="+mn-lt"/>
               </a:rPr>
-              <a:t> un Lπ≈156.8 </a:t>
+              <a:t> un Lπ≈156.82 </a:t>
             </a:r>
             <a:r>
               <a:rPr lang="en-US" sz="1200" dirty="0" err="1">
@@ -10183,15 +9619,12 @@
           </a:prstGeom>
         </p:spPr>
         <p:txBody>
-          <a:bodyPr vert="horz" wrap="square" lIns="0" tIns="12700" rIns="0" bIns="0" rtlCol="0">
+          <a:bodyPr vert="horz" wrap="square" lIns="0" tIns="12700" rIns="0" bIns="0" rtlCol="0" anchor="t">
             <a:spAutoFit/>
           </a:bodyPr>
           <a:lstStyle/>
           <a:p>
             <a:pPr marL="12700">
-              <a:lnSpc>
-                <a:spcPct val="100000"/>
-              </a:lnSpc>
               <a:spcBef>
                 <a:spcPts val="100"/>
               </a:spcBef>
@@ -10213,7 +9646,7 @@
             </a:r>
             <a:r>
               <a:rPr lang="en-US" b="0" dirty="0"/>
-              <a:t> = ? µm</a:t>
+              <a:t> = 10 µm</a:t>
             </a:r>
             <a:endParaRPr lang="en-US" sz="2500" b="0" dirty="0">
               <a:latin typeface="+mj-lt"/>
@@ -11701,7 +11134,7 @@
         <p:spPr>
           <a:xfrm>
             <a:off x="609441" y="4860334"/>
-            <a:ext cx="11199971" cy="1015663"/>
+            <a:ext cx="11199971" cy="1384995"/>
           </a:xfrm>
           <a:prstGeom prst="rect">
             <a:avLst/>
@@ -11718,7 +11151,7 @@
           </a:ln>
         </p:spPr>
         <p:txBody>
-          <a:bodyPr wrap="square" rtlCol="0">
+          <a:bodyPr wrap="square" lIns="91440" tIns="45720" rIns="91440" bIns="45720" rtlCol="0" anchor="t">
             <a:spAutoFit/>
           </a:bodyPr>
           <a:lstStyle/>
@@ -11726,32 +11159,898 @@
             <a:pPr algn="just"/>
             <a:r>
               <a:rPr lang="en-US" sz="1200" dirty="0">
-                <a:latin typeface="Arial" panose="020B0604020202020204" pitchFamily="34" charset="0"/>
-                <a:cs typeface="Arial" panose="020B0604020202020204" pitchFamily="34" charset="0"/>
-              </a:rPr>
-              <a:t>Make conclusions and observations from your results</a:t>
-            </a:r>
+                <a:ea typeface="+mn-lt"/>
+                <a:cs typeface="+mn-lt"/>
+              </a:rPr>
+              <a:t>Al </a:t>
+            </a:r>
+            <a:r>
+              <a:rPr lang="en-US" sz="1200" dirty="0" err="1">
+                <a:ea typeface="+mn-lt"/>
+                <a:cs typeface="+mn-lt"/>
+              </a:rPr>
+              <a:t>aumentar</a:t>
+            </a:r>
+            <a:r>
+              <a:rPr lang="en-US" sz="1200" dirty="0">
+                <a:ea typeface="+mn-lt"/>
+                <a:cs typeface="+mn-lt"/>
+              </a:rPr>
+              <a:t> </a:t>
+            </a:r>
+            <a:r>
+              <a:rPr lang="en-US" sz="1200" dirty="0" err="1">
+                <a:ea typeface="+mn-lt"/>
+                <a:cs typeface="+mn-lt"/>
+              </a:rPr>
+              <a:t>el</a:t>
+            </a:r>
+            <a:r>
+              <a:rPr lang="en-US" sz="1200" dirty="0">
+                <a:ea typeface="+mn-lt"/>
+                <a:cs typeface="+mn-lt"/>
+              </a:rPr>
+              <a:t> gap, la </a:t>
+            </a:r>
+            <a:r>
+              <a:rPr lang="en-US" sz="1200" dirty="0" err="1">
+                <a:ea typeface="+mn-lt"/>
+                <a:cs typeface="+mn-lt"/>
+              </a:rPr>
+              <a:t>longitud</a:t>
+            </a:r>
+            <a:r>
+              <a:rPr lang="en-US" sz="1200" dirty="0">
+                <a:ea typeface="+mn-lt"/>
+                <a:cs typeface="+mn-lt"/>
+              </a:rPr>
+              <a:t> de </a:t>
+            </a:r>
+            <a:r>
+              <a:rPr lang="en-US" sz="1200" dirty="0" err="1">
+                <a:ea typeface="+mn-lt"/>
+                <a:cs typeface="+mn-lt"/>
+              </a:rPr>
+              <a:t>acoplamiento</a:t>
+            </a:r>
+            <a:r>
+              <a:rPr lang="en-US" sz="1200" dirty="0">
+                <a:ea typeface="+mn-lt"/>
+                <a:cs typeface="+mn-lt"/>
+              </a:rPr>
+              <a:t> Lπ </a:t>
+            </a:r>
+            <a:r>
+              <a:rPr lang="en-US" sz="1200" dirty="0" err="1">
+                <a:ea typeface="+mn-lt"/>
+                <a:cs typeface="+mn-lt"/>
+              </a:rPr>
+              <a:t>crece</a:t>
+            </a:r>
+            <a:r>
+              <a:rPr lang="en-US" sz="1200" dirty="0">
+                <a:ea typeface="+mn-lt"/>
+                <a:cs typeface="+mn-lt"/>
+              </a:rPr>
+              <a:t> </a:t>
+            </a:r>
+            <a:r>
+              <a:rPr lang="en-US" sz="1200" dirty="0" err="1">
+                <a:ea typeface="+mn-lt"/>
+                <a:cs typeface="+mn-lt"/>
+              </a:rPr>
+              <a:t>rápidamente</a:t>
+            </a:r>
+            <a:r>
+              <a:rPr lang="en-US" sz="1200" dirty="0">
+                <a:ea typeface="+mn-lt"/>
+                <a:cs typeface="+mn-lt"/>
+              </a:rPr>
+              <a:t> </a:t>
+            </a:r>
+            <a:r>
+              <a:rPr lang="en-US" sz="1200" dirty="0" err="1">
+                <a:ea typeface="+mn-lt"/>
+                <a:cs typeface="+mn-lt"/>
+              </a:rPr>
+              <a:t>porque</a:t>
+            </a:r>
+            <a:r>
+              <a:rPr lang="en-US" sz="1200" dirty="0">
+                <a:ea typeface="+mn-lt"/>
+                <a:cs typeface="+mn-lt"/>
+              </a:rPr>
+              <a:t> </a:t>
+            </a:r>
+            <a:r>
+              <a:rPr lang="en-US" sz="1200" dirty="0" err="1">
+                <a:ea typeface="+mn-lt"/>
+                <a:cs typeface="+mn-lt"/>
+              </a:rPr>
+              <a:t>disminuye</a:t>
+            </a:r>
+            <a:r>
+              <a:rPr lang="en-US" sz="1200" dirty="0">
+                <a:ea typeface="+mn-lt"/>
+                <a:cs typeface="+mn-lt"/>
+              </a:rPr>
+              <a:t> </a:t>
+            </a:r>
+            <a:r>
+              <a:rPr lang="en-US" sz="1200" dirty="0" err="1">
+                <a:ea typeface="+mn-lt"/>
+                <a:cs typeface="+mn-lt"/>
+              </a:rPr>
+              <a:t>el</a:t>
+            </a:r>
+            <a:r>
+              <a:rPr lang="en-US" sz="1200" dirty="0">
+                <a:ea typeface="+mn-lt"/>
+                <a:cs typeface="+mn-lt"/>
+              </a:rPr>
+              <a:t> </a:t>
+            </a:r>
+            <a:r>
+              <a:rPr lang="en-US" sz="1200" dirty="0" err="1">
+                <a:ea typeface="+mn-lt"/>
+                <a:cs typeface="+mn-lt"/>
+              </a:rPr>
+              <a:t>solapamiento</a:t>
+            </a:r>
+            <a:r>
+              <a:rPr lang="en-US" sz="1200" dirty="0">
+                <a:ea typeface="+mn-lt"/>
+                <a:cs typeface="+mn-lt"/>
+              </a:rPr>
+              <a:t> entre </a:t>
+            </a:r>
+            <a:r>
+              <a:rPr lang="en-US" sz="1200" dirty="0" err="1">
+                <a:ea typeface="+mn-lt"/>
+                <a:cs typeface="+mn-lt"/>
+              </a:rPr>
+              <a:t>los</a:t>
+            </a:r>
+            <a:r>
+              <a:rPr lang="en-US" sz="1200" dirty="0">
+                <a:ea typeface="+mn-lt"/>
+                <a:cs typeface="+mn-lt"/>
+              </a:rPr>
+              <a:t> </a:t>
+            </a:r>
+            <a:r>
+              <a:rPr lang="en-US" sz="1200" dirty="0" err="1">
+                <a:ea typeface="+mn-lt"/>
+                <a:cs typeface="+mn-lt"/>
+              </a:rPr>
+              <a:t>modos</a:t>
+            </a:r>
+            <a:r>
+              <a:rPr lang="en-US" sz="1200" dirty="0">
+                <a:ea typeface="+mn-lt"/>
+                <a:cs typeface="+mn-lt"/>
+              </a:rPr>
+              <a:t> y, </a:t>
+            </a:r>
+            <a:r>
+              <a:rPr lang="en-US" sz="1200" dirty="0" err="1">
+                <a:ea typeface="+mn-lt"/>
+                <a:cs typeface="+mn-lt"/>
+              </a:rPr>
+              <a:t>por</a:t>
+            </a:r>
+            <a:r>
+              <a:rPr lang="en-US" sz="1200" dirty="0">
+                <a:ea typeface="+mn-lt"/>
+                <a:cs typeface="+mn-lt"/>
+              </a:rPr>
+              <a:t> tanto, la </a:t>
+            </a:r>
+            <a:r>
+              <a:rPr lang="en-US" sz="1200" dirty="0" err="1">
+                <a:ea typeface="+mn-lt"/>
+                <a:cs typeface="+mn-lt"/>
+              </a:rPr>
+              <a:t>diferencia</a:t>
+            </a:r>
+            <a:r>
+              <a:rPr lang="en-US" sz="1200" dirty="0">
+                <a:ea typeface="+mn-lt"/>
+                <a:cs typeface="+mn-lt"/>
+              </a:rPr>
+              <a:t> de </a:t>
+            </a:r>
+            <a:r>
+              <a:rPr lang="en-US" sz="1200" dirty="0" err="1">
+                <a:ea typeface="+mn-lt"/>
+                <a:cs typeface="+mn-lt"/>
+              </a:rPr>
+              <a:t>índices</a:t>
+            </a:r>
+            <a:r>
+              <a:rPr lang="en-US" sz="1200" dirty="0">
+                <a:ea typeface="+mn-lt"/>
+                <a:cs typeface="+mn-lt"/>
+              </a:rPr>
+              <a:t> </a:t>
+            </a:r>
+            <a:r>
+              <a:rPr lang="en-US" sz="1200" dirty="0" err="1">
+                <a:ea typeface="+mn-lt"/>
+                <a:cs typeface="+mn-lt"/>
+              </a:rPr>
+              <a:t>efectivos</a:t>
+            </a:r>
+            <a:r>
+              <a:rPr lang="en-US" sz="1200" dirty="0">
+                <a:ea typeface="+mn-lt"/>
+                <a:cs typeface="+mn-lt"/>
+              </a:rPr>
+              <a:t> (</a:t>
+            </a:r>
+            <a:r>
+              <a:rPr lang="en-US" sz="1200" dirty="0" err="1">
+                <a:ea typeface="+mn-lt"/>
+                <a:cs typeface="+mn-lt"/>
+              </a:rPr>
+              <a:t>Δneff</a:t>
+            </a:r>
+            <a:r>
+              <a:rPr lang="en-US" sz="1200" dirty="0">
+                <a:ea typeface="+mn-lt"/>
+                <a:cs typeface="+mn-lt"/>
+              </a:rPr>
+              <a:t>). Como Lπ  es </a:t>
+            </a:r>
+            <a:r>
+              <a:rPr lang="en-US" sz="1200" dirty="0" err="1">
+                <a:ea typeface="+mn-lt"/>
+                <a:cs typeface="+mn-lt"/>
+              </a:rPr>
+              <a:t>inversamente</a:t>
+            </a:r>
+            <a:r>
+              <a:rPr lang="en-US" sz="1200" dirty="0">
+                <a:ea typeface="+mn-lt"/>
+                <a:cs typeface="+mn-lt"/>
+              </a:rPr>
+              <a:t> </a:t>
+            </a:r>
+            <a:r>
+              <a:rPr lang="en-US" sz="1200" dirty="0" err="1">
+                <a:ea typeface="+mn-lt"/>
+                <a:cs typeface="+mn-lt"/>
+              </a:rPr>
+              <a:t>proporcional</a:t>
+            </a:r>
+            <a:r>
+              <a:rPr lang="en-US" sz="1200" dirty="0">
+                <a:ea typeface="+mn-lt"/>
+                <a:cs typeface="+mn-lt"/>
+              </a:rPr>
+              <a:t> a </a:t>
+            </a:r>
+            <a:r>
+              <a:rPr lang="en-US" sz="1200" dirty="0" err="1">
+                <a:ea typeface="+mn-lt"/>
+                <a:cs typeface="+mn-lt"/>
+              </a:rPr>
+              <a:t>Δneff</a:t>
+            </a:r>
+            <a:r>
+              <a:rPr lang="en-US" sz="1200" dirty="0">
+                <a:ea typeface="+mn-lt"/>
+                <a:cs typeface="+mn-lt"/>
+              </a:rPr>
+              <a:t>, </a:t>
+            </a:r>
+            <a:r>
+              <a:rPr lang="en-US" sz="1200" dirty="0" err="1">
+                <a:ea typeface="+mn-lt"/>
+                <a:cs typeface="+mn-lt"/>
+              </a:rPr>
+              <a:t>cuando</a:t>
+            </a:r>
+            <a:r>
+              <a:rPr lang="en-US" sz="1200" dirty="0">
+                <a:ea typeface="+mn-lt"/>
+                <a:cs typeface="+mn-lt"/>
+              </a:rPr>
+              <a:t> </a:t>
+            </a:r>
+            <a:r>
+              <a:rPr lang="en-US" sz="1200" dirty="0" err="1">
+                <a:ea typeface="+mn-lt"/>
+                <a:cs typeface="+mn-lt"/>
+              </a:rPr>
+              <a:t>esta</a:t>
+            </a:r>
+            <a:r>
+              <a:rPr lang="en-US" sz="1200" dirty="0">
+                <a:ea typeface="+mn-lt"/>
+                <a:cs typeface="+mn-lt"/>
+              </a:rPr>
+              <a:t> </a:t>
+            </a:r>
+            <a:r>
+              <a:rPr lang="en-US" sz="1200" dirty="0" err="1">
+                <a:ea typeface="+mn-lt"/>
+                <a:cs typeface="+mn-lt"/>
+              </a:rPr>
+              <a:t>tiende</a:t>
+            </a:r>
+            <a:r>
+              <a:rPr lang="en-US" sz="1200" dirty="0">
+                <a:ea typeface="+mn-lt"/>
+                <a:cs typeface="+mn-lt"/>
+              </a:rPr>
+              <a:t> a cero, Lπ  se </a:t>
+            </a:r>
+            <a:r>
+              <a:rPr lang="en-US" sz="1200" dirty="0" err="1">
+                <a:ea typeface="+mn-lt"/>
+                <a:cs typeface="+mn-lt"/>
+              </a:rPr>
+              <a:t>dispara</a:t>
+            </a:r>
+            <a:r>
+              <a:rPr lang="en-US" sz="1200" dirty="0">
+                <a:ea typeface="+mn-lt"/>
+                <a:cs typeface="+mn-lt"/>
+              </a:rPr>
+              <a:t> a </a:t>
+            </a:r>
+            <a:r>
+              <a:rPr lang="en-US" sz="1200" dirty="0" err="1">
+                <a:ea typeface="+mn-lt"/>
+                <a:cs typeface="+mn-lt"/>
+              </a:rPr>
+              <a:t>valores</a:t>
+            </a:r>
+            <a:r>
+              <a:rPr lang="en-US" sz="1200" dirty="0">
+                <a:ea typeface="+mn-lt"/>
+                <a:cs typeface="+mn-lt"/>
+              </a:rPr>
+              <a:t> </a:t>
+            </a:r>
+            <a:r>
+              <a:rPr lang="en-US" sz="1200" dirty="0" err="1">
+                <a:ea typeface="+mn-lt"/>
+                <a:cs typeface="+mn-lt"/>
+              </a:rPr>
+              <a:t>muy</a:t>
+            </a:r>
+            <a:r>
+              <a:rPr lang="en-US" sz="1200" dirty="0">
+                <a:ea typeface="+mn-lt"/>
+                <a:cs typeface="+mn-lt"/>
+              </a:rPr>
+              <a:t> altos.</a:t>
+            </a:r>
+            <a:endParaRPr lang="es-ES" dirty="0"/>
           </a:p>
           <a:p>
             <a:pPr algn="just"/>
             <a:endParaRPr lang="en-US" sz="1200" dirty="0">
-              <a:latin typeface="Arial" panose="020B0604020202020204" pitchFamily="34" charset="0"/>
-              <a:cs typeface="Arial" panose="020B0604020202020204" pitchFamily="34" charset="0"/>
+              <a:ea typeface="+mn-lt"/>
+              <a:cs typeface="+mn-lt"/>
             </a:endParaRPr>
           </a:p>
           <a:p>
             <a:pPr algn="just"/>
-            <a:endParaRPr lang="en-US" sz="1200" dirty="0">
-              <a:latin typeface="Arial" panose="020B0604020202020204" pitchFamily="34" charset="0"/>
-              <a:cs typeface="Arial" panose="020B0604020202020204" pitchFamily="34" charset="0"/>
-            </a:endParaRPr>
-          </a:p>
-          <a:p>
-            <a:pPr algn="just"/>
-            <a:endParaRPr lang="en-US" sz="1200" dirty="0">
-              <a:latin typeface="Arial" panose="020B0604020202020204" pitchFamily="34" charset="0"/>
-              <a:cs typeface="Arial" panose="020B0604020202020204" pitchFamily="34" charset="0"/>
-            </a:endParaRPr>
+            <a:r>
+              <a:rPr lang="en-US" sz="1200" dirty="0">
+                <a:ea typeface="+mn-lt"/>
+                <a:cs typeface="+mn-lt"/>
+              </a:rPr>
+              <a:t>En la </a:t>
+            </a:r>
+            <a:r>
+              <a:rPr lang="en-US" sz="1200" dirty="0" err="1">
+                <a:ea typeface="+mn-lt"/>
+                <a:cs typeface="+mn-lt"/>
+              </a:rPr>
+              <a:t>configuración</a:t>
+            </a:r>
+            <a:r>
+              <a:rPr lang="en-US" sz="1200" dirty="0">
+                <a:ea typeface="+mn-lt"/>
+                <a:cs typeface="+mn-lt"/>
+              </a:rPr>
+              <a:t> </a:t>
+            </a:r>
+            <a:r>
+              <a:rPr lang="en-US" sz="1200" b="1" dirty="0">
+                <a:ea typeface="+mn-lt"/>
+                <a:cs typeface="+mn-lt"/>
+              </a:rPr>
+              <a:t>deep</a:t>
+            </a:r>
+            <a:r>
+              <a:rPr lang="en-US" sz="1200" dirty="0">
+                <a:ea typeface="+mn-lt"/>
+                <a:cs typeface="+mn-lt"/>
+              </a:rPr>
+              <a:t>, </a:t>
+            </a:r>
+            <a:r>
+              <a:rPr lang="en-US" sz="1200" dirty="0" err="1">
+                <a:ea typeface="+mn-lt"/>
+                <a:cs typeface="+mn-lt"/>
+              </a:rPr>
+              <a:t>el</a:t>
+            </a:r>
+            <a:r>
+              <a:rPr lang="en-US" sz="1200" dirty="0">
+                <a:ea typeface="+mn-lt"/>
+                <a:cs typeface="+mn-lt"/>
+              </a:rPr>
+              <a:t> </a:t>
+            </a:r>
+            <a:r>
+              <a:rPr lang="en-US" sz="1200" dirty="0" err="1">
+                <a:ea typeface="+mn-lt"/>
+                <a:cs typeface="+mn-lt"/>
+              </a:rPr>
+              <a:t>confinamiento</a:t>
+            </a:r>
+            <a:r>
+              <a:rPr lang="en-US" sz="1200" dirty="0">
+                <a:ea typeface="+mn-lt"/>
+                <a:cs typeface="+mn-lt"/>
+              </a:rPr>
+              <a:t> es mayor y </a:t>
+            </a:r>
+            <a:r>
+              <a:rPr lang="en-US" sz="1200" dirty="0" err="1">
+                <a:ea typeface="+mn-lt"/>
+                <a:cs typeface="+mn-lt"/>
+              </a:rPr>
+              <a:t>el</a:t>
+            </a:r>
+            <a:r>
+              <a:rPr lang="en-US" sz="1200" dirty="0">
+                <a:ea typeface="+mn-lt"/>
+                <a:cs typeface="+mn-lt"/>
+              </a:rPr>
+              <a:t> </a:t>
+            </a:r>
+            <a:r>
+              <a:rPr lang="en-US" sz="1200" dirty="0" err="1">
+                <a:ea typeface="+mn-lt"/>
+                <a:cs typeface="+mn-lt"/>
+              </a:rPr>
+              <a:t>acoplamiento</a:t>
+            </a:r>
+            <a:r>
+              <a:rPr lang="en-US" sz="1200" dirty="0">
+                <a:ea typeface="+mn-lt"/>
+                <a:cs typeface="+mn-lt"/>
+              </a:rPr>
+              <a:t> se </a:t>
+            </a:r>
+            <a:r>
+              <a:rPr lang="en-US" sz="1200" dirty="0" err="1">
+                <a:ea typeface="+mn-lt"/>
+                <a:cs typeface="+mn-lt"/>
+              </a:rPr>
+              <a:t>mantiene</a:t>
+            </a:r>
+            <a:r>
+              <a:rPr lang="en-US" sz="1200" dirty="0">
+                <a:ea typeface="+mn-lt"/>
+                <a:cs typeface="+mn-lt"/>
+              </a:rPr>
+              <a:t> </a:t>
+            </a:r>
+            <a:r>
+              <a:rPr lang="en-US" sz="1200" dirty="0" err="1">
+                <a:ea typeface="+mn-lt"/>
+                <a:cs typeface="+mn-lt"/>
+              </a:rPr>
+              <a:t>más</a:t>
+            </a:r>
+            <a:r>
+              <a:rPr lang="en-US" sz="1200" dirty="0">
+                <a:ea typeface="+mn-lt"/>
+                <a:cs typeface="+mn-lt"/>
+              </a:rPr>
+              <a:t> </a:t>
+            </a:r>
+            <a:r>
+              <a:rPr lang="en-US" sz="1200" dirty="0" err="1">
+                <a:ea typeface="+mn-lt"/>
+                <a:cs typeface="+mn-lt"/>
+              </a:rPr>
+              <a:t>estable</a:t>
+            </a:r>
+            <a:r>
+              <a:rPr lang="en-US" sz="1200" dirty="0">
+                <a:ea typeface="+mn-lt"/>
+                <a:cs typeface="+mn-lt"/>
+              </a:rPr>
+              <a:t>, </a:t>
+            </a:r>
+            <a:r>
+              <a:rPr lang="en-US" sz="1200" dirty="0" err="1">
+                <a:ea typeface="+mn-lt"/>
+                <a:cs typeface="+mn-lt"/>
+              </a:rPr>
+              <a:t>por</a:t>
+            </a:r>
+            <a:r>
+              <a:rPr lang="en-US" sz="1200" dirty="0">
+                <a:ea typeface="+mn-lt"/>
+                <a:cs typeface="+mn-lt"/>
+              </a:rPr>
+              <a:t> lo </a:t>
+            </a:r>
+            <a:r>
+              <a:rPr lang="en-US" sz="1200" dirty="0" err="1">
+                <a:ea typeface="+mn-lt"/>
+                <a:cs typeface="+mn-lt"/>
+              </a:rPr>
+              <a:t>que</a:t>
+            </a:r>
+            <a:r>
+              <a:rPr lang="en-US" sz="1200" dirty="0">
+                <a:ea typeface="+mn-lt"/>
+                <a:cs typeface="+mn-lt"/>
+              </a:rPr>
+              <a:t> Lπ </a:t>
+            </a:r>
+            <a:r>
+              <a:rPr lang="en-US" sz="1200" dirty="0" err="1">
+                <a:ea typeface="+mn-lt"/>
+                <a:cs typeface="+mn-lt"/>
+              </a:rPr>
+              <a:t>crece</a:t>
+            </a:r>
+            <a:r>
+              <a:rPr lang="en-US" sz="1200" dirty="0">
+                <a:ea typeface="+mn-lt"/>
+                <a:cs typeface="+mn-lt"/>
+              </a:rPr>
+              <a:t> de forma </a:t>
+            </a:r>
+            <a:r>
+              <a:rPr lang="en-US" sz="1200" dirty="0" err="1">
+                <a:ea typeface="+mn-lt"/>
+                <a:cs typeface="+mn-lt"/>
+              </a:rPr>
+              <a:t>progresiva</a:t>
+            </a:r>
+            <a:r>
+              <a:rPr lang="en-US" sz="1200" dirty="0">
+                <a:ea typeface="+mn-lt"/>
+                <a:cs typeface="+mn-lt"/>
+              </a:rPr>
+              <a:t>. En </a:t>
+            </a:r>
+            <a:r>
+              <a:rPr lang="en-US" sz="1200" dirty="0" err="1">
+                <a:ea typeface="+mn-lt"/>
+                <a:cs typeface="+mn-lt"/>
+              </a:rPr>
+              <a:t>cambio</a:t>
+            </a:r>
+            <a:r>
+              <a:rPr lang="en-US" sz="1200" dirty="0">
+                <a:ea typeface="+mn-lt"/>
+                <a:cs typeface="+mn-lt"/>
+              </a:rPr>
+              <a:t>, </a:t>
+            </a:r>
+            <a:r>
+              <a:rPr lang="en-US" sz="1200" dirty="0" err="1">
+                <a:ea typeface="+mn-lt"/>
+                <a:cs typeface="+mn-lt"/>
+              </a:rPr>
+              <a:t>en</a:t>
+            </a:r>
+            <a:r>
+              <a:rPr lang="en-US" sz="1200" dirty="0">
+                <a:ea typeface="+mn-lt"/>
+                <a:cs typeface="+mn-lt"/>
+              </a:rPr>
+              <a:t> </a:t>
+            </a:r>
+            <a:r>
+              <a:rPr lang="en-US" sz="1200" b="1" dirty="0">
+                <a:ea typeface="+mn-lt"/>
+                <a:cs typeface="+mn-lt"/>
+              </a:rPr>
+              <a:t>shallow</a:t>
+            </a:r>
+            <a:r>
+              <a:rPr lang="en-US" sz="1200" dirty="0">
+                <a:ea typeface="+mn-lt"/>
+                <a:cs typeface="+mn-lt"/>
+              </a:rPr>
+              <a:t>, </a:t>
+            </a:r>
+            <a:r>
+              <a:rPr lang="en-US" sz="1200" dirty="0" err="1">
+                <a:ea typeface="+mn-lt"/>
+                <a:cs typeface="+mn-lt"/>
+              </a:rPr>
+              <a:t>el</a:t>
+            </a:r>
+            <a:r>
+              <a:rPr lang="en-US" sz="1200" dirty="0">
+                <a:ea typeface="+mn-lt"/>
+                <a:cs typeface="+mn-lt"/>
+              </a:rPr>
+              <a:t> modo (</a:t>
+            </a:r>
+            <a:r>
+              <a:rPr lang="en-US" sz="1200" dirty="0" err="1">
+                <a:ea typeface="+mn-lt"/>
+                <a:cs typeface="+mn-lt"/>
+              </a:rPr>
+              <a:t>especialmente</a:t>
+            </a:r>
+            <a:r>
+              <a:rPr lang="en-US" sz="1200" dirty="0">
+                <a:ea typeface="+mn-lt"/>
+                <a:cs typeface="+mn-lt"/>
+              </a:rPr>
+              <a:t> TM) </a:t>
+            </a:r>
+            <a:r>
+              <a:rPr lang="en-US" sz="1200" dirty="0" err="1">
+                <a:ea typeface="+mn-lt"/>
+                <a:cs typeface="+mn-lt"/>
+              </a:rPr>
+              <a:t>está</a:t>
+            </a:r>
+            <a:r>
+              <a:rPr lang="en-US" sz="1200" dirty="0">
+                <a:ea typeface="+mn-lt"/>
+                <a:cs typeface="+mn-lt"/>
+              </a:rPr>
+              <a:t> </a:t>
+            </a:r>
+            <a:r>
+              <a:rPr lang="en-US" sz="1200" dirty="0" err="1">
+                <a:ea typeface="+mn-lt"/>
+                <a:cs typeface="+mn-lt"/>
+              </a:rPr>
+              <a:t>menos</a:t>
+            </a:r>
+            <a:r>
+              <a:rPr lang="en-US" sz="1200" dirty="0">
+                <a:ea typeface="+mn-lt"/>
+                <a:cs typeface="+mn-lt"/>
+              </a:rPr>
+              <a:t> </a:t>
+            </a:r>
+            <a:r>
+              <a:rPr lang="en-US" sz="1200" dirty="0" err="1">
+                <a:ea typeface="+mn-lt"/>
+                <a:cs typeface="+mn-lt"/>
+              </a:rPr>
+              <a:t>confinado</a:t>
+            </a:r>
+            <a:r>
+              <a:rPr lang="en-US" sz="1200" dirty="0">
+                <a:ea typeface="+mn-lt"/>
+                <a:cs typeface="+mn-lt"/>
+              </a:rPr>
+              <a:t> </a:t>
+            </a:r>
+            <a:r>
+              <a:rPr lang="en-US" sz="1200" dirty="0" err="1">
+                <a:ea typeface="+mn-lt"/>
+                <a:cs typeface="+mn-lt"/>
+              </a:rPr>
+              <a:t>debido</a:t>
+            </a:r>
+            <a:r>
+              <a:rPr lang="en-US" sz="1200" dirty="0">
+                <a:ea typeface="+mn-lt"/>
+                <a:cs typeface="+mn-lt"/>
+              </a:rPr>
+              <a:t> al slab, lo </a:t>
+            </a:r>
+            <a:r>
+              <a:rPr lang="en-US" sz="1200" dirty="0" err="1">
+                <a:ea typeface="+mn-lt"/>
+                <a:cs typeface="+mn-lt"/>
+              </a:rPr>
+              <a:t>que</a:t>
+            </a:r>
+            <a:r>
+              <a:rPr lang="en-US" sz="1200" dirty="0">
+                <a:ea typeface="+mn-lt"/>
+                <a:cs typeface="+mn-lt"/>
+              </a:rPr>
+              <a:t> </a:t>
+            </a:r>
+            <a:r>
+              <a:rPr lang="en-US" sz="1200" dirty="0" err="1">
+                <a:ea typeface="+mn-lt"/>
+                <a:cs typeface="+mn-lt"/>
+              </a:rPr>
+              <a:t>hace</a:t>
+            </a:r>
+            <a:r>
+              <a:rPr lang="en-US" sz="1200" dirty="0">
+                <a:ea typeface="+mn-lt"/>
+                <a:cs typeface="+mn-lt"/>
+              </a:rPr>
+              <a:t> </a:t>
+            </a:r>
+            <a:r>
+              <a:rPr lang="en-US" sz="1200" dirty="0" err="1">
+                <a:ea typeface="+mn-lt"/>
+                <a:cs typeface="+mn-lt"/>
+              </a:rPr>
+              <a:t>que</a:t>
+            </a:r>
+            <a:r>
+              <a:rPr lang="en-US" sz="1200" dirty="0">
+                <a:ea typeface="+mn-lt"/>
+                <a:cs typeface="+mn-lt"/>
+              </a:rPr>
+              <a:t> </a:t>
+            </a:r>
+            <a:r>
+              <a:rPr lang="en-US" sz="1200" dirty="0" err="1">
+                <a:ea typeface="+mn-lt"/>
+                <a:cs typeface="+mn-lt"/>
+              </a:rPr>
+              <a:t>Δneff</a:t>
+            </a:r>
+            <a:r>
+              <a:rPr lang="en-US" sz="1200" dirty="0">
+                <a:ea typeface="+mn-lt"/>
+                <a:cs typeface="+mn-lt"/>
+              </a:rPr>
+              <a:t> </a:t>
+            </a:r>
+            <a:r>
+              <a:rPr lang="en-US" sz="1200" dirty="0" err="1">
+                <a:ea typeface="+mn-lt"/>
+                <a:cs typeface="+mn-lt"/>
+              </a:rPr>
+              <a:t>disminuya</a:t>
+            </a:r>
+            <a:r>
+              <a:rPr lang="en-US" sz="1200" dirty="0">
+                <a:ea typeface="+mn-lt"/>
+                <a:cs typeface="+mn-lt"/>
+              </a:rPr>
+              <a:t> </a:t>
+            </a:r>
+            <a:r>
+              <a:rPr lang="en-US" sz="1200" dirty="0" err="1">
+                <a:ea typeface="+mn-lt"/>
+                <a:cs typeface="+mn-lt"/>
+              </a:rPr>
+              <a:t>más</a:t>
+            </a:r>
+            <a:r>
+              <a:rPr lang="en-US" sz="1200" dirty="0">
+                <a:ea typeface="+mn-lt"/>
+                <a:cs typeface="+mn-lt"/>
+              </a:rPr>
+              <a:t> </a:t>
+            </a:r>
+            <a:r>
+              <a:rPr lang="en-US" sz="1200" dirty="0" err="1">
+                <a:ea typeface="+mn-lt"/>
+                <a:cs typeface="+mn-lt"/>
+              </a:rPr>
+              <a:t>rápido</a:t>
+            </a:r>
+            <a:r>
+              <a:rPr lang="en-US" sz="1200" dirty="0">
+                <a:ea typeface="+mn-lt"/>
+                <a:cs typeface="+mn-lt"/>
+              </a:rPr>
+              <a:t> y Lπ </a:t>
+            </a:r>
+            <a:r>
+              <a:rPr lang="en-US" sz="1200" dirty="0" err="1">
+                <a:ea typeface="+mn-lt"/>
+                <a:cs typeface="+mn-lt"/>
+              </a:rPr>
+              <a:t>aumente</a:t>
+            </a:r>
+            <a:r>
+              <a:rPr lang="en-US" sz="1200" dirty="0">
+                <a:ea typeface="+mn-lt"/>
+                <a:cs typeface="+mn-lt"/>
+              </a:rPr>
+              <a:t> </a:t>
+            </a:r>
+            <a:r>
+              <a:rPr lang="en-US" sz="1200" dirty="0" err="1">
+                <a:ea typeface="+mn-lt"/>
+                <a:cs typeface="+mn-lt"/>
+              </a:rPr>
+              <a:t>mucho</a:t>
+            </a:r>
+            <a:r>
+              <a:rPr lang="en-US" sz="1200" dirty="0">
+                <a:ea typeface="+mn-lt"/>
+                <a:cs typeface="+mn-lt"/>
+              </a:rPr>
+              <a:t> </a:t>
+            </a:r>
+            <a:r>
+              <a:rPr lang="en-US" sz="1200" dirty="0" err="1">
+                <a:ea typeface="+mn-lt"/>
+                <a:cs typeface="+mn-lt"/>
+              </a:rPr>
+              <a:t>más</a:t>
+            </a:r>
+            <a:r>
+              <a:rPr lang="en-US" sz="1200" dirty="0">
+                <a:ea typeface="+mn-lt"/>
+                <a:cs typeface="+mn-lt"/>
+              </a:rPr>
+              <a:t> </a:t>
+            </a:r>
+            <a:r>
+              <a:rPr lang="en-US" sz="1200" dirty="0" err="1">
+                <a:ea typeface="+mn-lt"/>
+                <a:cs typeface="+mn-lt"/>
+              </a:rPr>
+              <a:t>bruscamente</a:t>
+            </a:r>
+            <a:r>
+              <a:rPr lang="en-US" sz="1200" dirty="0">
+                <a:ea typeface="+mn-lt"/>
+                <a:cs typeface="+mn-lt"/>
+              </a:rPr>
+              <a:t>, </a:t>
+            </a:r>
+            <a:r>
+              <a:rPr lang="en-US" sz="1200" dirty="0" err="1">
+                <a:ea typeface="+mn-lt"/>
+                <a:cs typeface="+mn-lt"/>
+              </a:rPr>
+              <a:t>llegando</a:t>
+            </a:r>
+            <a:r>
+              <a:rPr lang="en-US" sz="1200" dirty="0">
+                <a:ea typeface="+mn-lt"/>
+                <a:cs typeface="+mn-lt"/>
+              </a:rPr>
+              <a:t> a </a:t>
+            </a:r>
+            <a:r>
+              <a:rPr lang="en-US" sz="1200" dirty="0" err="1">
+                <a:ea typeface="+mn-lt"/>
+                <a:cs typeface="+mn-lt"/>
+              </a:rPr>
+              <a:t>valores</a:t>
+            </a:r>
+            <a:r>
+              <a:rPr lang="en-US" sz="1200" dirty="0">
+                <a:ea typeface="+mn-lt"/>
+                <a:cs typeface="+mn-lt"/>
+              </a:rPr>
+              <a:t> </a:t>
+            </a:r>
+            <a:r>
+              <a:rPr lang="en-US" sz="1200" dirty="0" err="1">
+                <a:ea typeface="+mn-lt"/>
+                <a:cs typeface="+mn-lt"/>
+              </a:rPr>
+              <a:t>extremadamente</a:t>
+            </a:r>
+            <a:r>
+              <a:rPr lang="en-US" sz="1200" dirty="0">
+                <a:ea typeface="+mn-lt"/>
+                <a:cs typeface="+mn-lt"/>
+              </a:rPr>
+              <a:t> altos</a:t>
+            </a:r>
+            <a:endParaRPr lang="en-US" dirty="0"/>
           </a:p>
           <a:p>
             <a:pPr algn="just"/>
@@ -11863,42 +12162,6 @@
           <a:p>
             <a:pPr algn="ctr"/>
             <a:endParaRPr lang="en-US"/>
-          </a:p>
-        </p:txBody>
-      </p:sp>
-      <p:sp>
-        <p:nvSpPr>
-          <p:cNvPr id="7" name="CuadroTexto 6">
-            <a:extLst>
-              <a:ext uri="{FF2B5EF4-FFF2-40B4-BE49-F238E27FC236}">
-                <a16:creationId xmlns:a16="http://schemas.microsoft.com/office/drawing/2014/main" id="{6D309BFB-98FD-0CBA-3C6A-346D8859893B}"/>
-              </a:ext>
-            </a:extLst>
-          </p:cNvPr>
-          <p:cNvSpPr txBox="1"/>
-          <p:nvPr/>
-        </p:nvSpPr>
-        <p:spPr>
-          <a:xfrm>
-            <a:off x="6331152" y="4342178"/>
-            <a:ext cx="2269787" cy="369332"/>
-          </a:xfrm>
-          <a:prstGeom prst="rect">
-            <a:avLst/>
-          </a:prstGeom>
-          <a:noFill/>
-        </p:spPr>
-        <p:txBody>
-          <a:bodyPr wrap="square">
-            <a:spAutoFit/>
-          </a:bodyPr>
-          <a:lstStyle/>
-          <a:p>
-            <a:r>
-              <a:rPr lang="en-US" dirty="0"/>
-              <a:t>slab = 150nm</a:t>
-            </a:r>
-            <a:endParaRPr lang="es-ES" dirty="0"/>
           </a:p>
         </p:txBody>
       </p:sp>
@@ -12166,6 +12429,66 @@
           </p:sp>
         </mc:Fallback>
       </mc:AlternateContent>
+      <p:pic>
+        <p:nvPicPr>
+          <p:cNvPr id="4" name="Imagen 3" descr="Gráfico, Gráfico de líneas&#10;&#10;El contenido generado por IA puede ser incorrecto.">
+            <a:extLst>
+              <a:ext uri="{FF2B5EF4-FFF2-40B4-BE49-F238E27FC236}">
+                <a16:creationId xmlns:a16="http://schemas.microsoft.com/office/drawing/2014/main" id="{1DDF2C08-6034-8853-86B8-DE9E8348AA96}"/>
+              </a:ext>
+            </a:extLst>
+          </p:cNvPr>
+          <p:cNvPicPr>
+            <a:picLocks noChangeAspect="1"/>
+          </p:cNvPicPr>
+          <p:nvPr/>
+        </p:nvPicPr>
+        <p:blipFill>
+          <a:blip r:embed="rId7"/>
+          <a:stretch>
+            <a:fillRect/>
+          </a:stretch>
+        </p:blipFill>
+        <p:spPr>
+          <a:xfrm>
+            <a:off x="1215902" y="1449631"/>
+            <a:ext cx="4267933" cy="3302245"/>
+          </a:xfrm>
+          <a:prstGeom prst="rect">
+            <a:avLst/>
+          </a:prstGeom>
+        </p:spPr>
+      </p:pic>
+      <p:pic>
+        <p:nvPicPr>
+          <p:cNvPr id="10" name="Imagen 9" descr="Gráfico, Gráfico de líneas&#10;&#10;El contenido generado por IA puede ser incorrecto.">
+            <a:extLst>
+              <a:ext uri="{FF2B5EF4-FFF2-40B4-BE49-F238E27FC236}">
+                <a16:creationId xmlns:a16="http://schemas.microsoft.com/office/drawing/2014/main" id="{76F89DE6-87DF-D4D7-217E-B208CDE6DA8A}"/>
+              </a:ext>
+            </a:extLst>
+          </p:cNvPr>
+          <p:cNvPicPr>
+            <a:picLocks noChangeAspect="1"/>
+          </p:cNvPicPr>
+          <p:nvPr/>
+        </p:nvPicPr>
+        <p:blipFill>
+          <a:blip r:embed="rId8"/>
+          <a:stretch>
+            <a:fillRect/>
+          </a:stretch>
+        </p:blipFill>
+        <p:spPr>
+          <a:xfrm>
+            <a:off x="7018824" y="1508071"/>
+            <a:ext cx="4267932" cy="3185363"/>
+          </a:xfrm>
+          <a:prstGeom prst="rect">
+            <a:avLst/>
+          </a:prstGeom>
+        </p:spPr>
+      </p:pic>
     </p:spTree>
     <p:extLst>
       <p:ext uri="{BB962C8B-B14F-4D97-AF65-F5344CB8AC3E}">
@@ -12407,7 +12730,7 @@
           </a:ln>
         </p:spPr>
         <p:txBody>
-          <a:bodyPr wrap="square" rtlCol="0">
+          <a:bodyPr wrap="square" lIns="91440" tIns="45720" rIns="91440" bIns="45720" rtlCol="0" anchor="t">
             <a:spAutoFit/>
           </a:bodyPr>
           <a:lstStyle/>
@@ -12415,39 +12738,1034 @@
             <a:pPr algn="just"/>
             <a:r>
               <a:rPr lang="en-US" sz="1200" dirty="0">
-                <a:latin typeface="Arial" panose="020B0604020202020204" pitchFamily="34" charset="0"/>
-                <a:cs typeface="Arial" panose="020B0604020202020204" pitchFamily="34" charset="0"/>
-              </a:rPr>
-              <a:t>Comment results</a:t>
-            </a:r>
-          </a:p>
-          <a:p>
-            <a:pPr algn="just"/>
-            <a:endParaRPr lang="en-US" sz="1200" dirty="0">
-              <a:latin typeface="Arial" panose="020B0604020202020204" pitchFamily="34" charset="0"/>
-              <a:cs typeface="Arial" panose="020B0604020202020204" pitchFamily="34" charset="0"/>
-            </a:endParaRPr>
-          </a:p>
-          <a:p>
-            <a:pPr algn="just"/>
-            <a:endParaRPr lang="en-US" sz="1200" dirty="0">
-              <a:latin typeface="Arial" panose="020B0604020202020204" pitchFamily="34" charset="0"/>
-              <a:cs typeface="Arial" panose="020B0604020202020204" pitchFamily="34" charset="0"/>
-            </a:endParaRPr>
-          </a:p>
-          <a:p>
-            <a:pPr algn="just"/>
-            <a:endParaRPr lang="en-US" sz="1200" dirty="0">
-              <a:latin typeface="Arial" panose="020B0604020202020204" pitchFamily="34" charset="0"/>
-              <a:cs typeface="Arial" panose="020B0604020202020204" pitchFamily="34" charset="0"/>
-            </a:endParaRPr>
-          </a:p>
-          <a:p>
-            <a:pPr algn="just"/>
-            <a:endParaRPr lang="en-US" sz="1200" dirty="0">
-              <a:latin typeface="Arial" panose="020B0604020202020204" pitchFamily="34" charset="0"/>
-              <a:cs typeface="Arial" panose="020B0604020202020204" pitchFamily="34" charset="0"/>
-            </a:endParaRPr>
+                <a:ea typeface="+mn-lt"/>
+                <a:cs typeface="+mn-lt"/>
+              </a:rPr>
+              <a:t>La </a:t>
+            </a:r>
+            <a:r>
+              <a:rPr lang="en-US" sz="1200" dirty="0" err="1">
+                <a:ea typeface="+mn-lt"/>
+                <a:cs typeface="+mn-lt"/>
+              </a:rPr>
+              <a:t>longitud</a:t>
+            </a:r>
+            <a:r>
+              <a:rPr lang="en-US" sz="1200" dirty="0">
+                <a:ea typeface="+mn-lt"/>
+                <a:cs typeface="+mn-lt"/>
+              </a:rPr>
+              <a:t> de </a:t>
+            </a:r>
+            <a:r>
+              <a:rPr lang="en-US" sz="1200" dirty="0" err="1">
+                <a:ea typeface="+mn-lt"/>
+                <a:cs typeface="+mn-lt"/>
+              </a:rPr>
+              <a:t>acoplo</a:t>
+            </a:r>
+            <a:r>
+              <a:rPr lang="en-US" sz="1200" dirty="0">
+                <a:ea typeface="+mn-lt"/>
+                <a:cs typeface="+mn-lt"/>
+              </a:rPr>
+              <a:t> Lπ  </a:t>
+            </a:r>
+            <a:r>
+              <a:rPr lang="en-US" sz="1200" dirty="0" err="1">
+                <a:ea typeface="+mn-lt"/>
+                <a:cs typeface="+mn-lt"/>
+              </a:rPr>
+              <a:t>disminuye</a:t>
+            </a:r>
+            <a:r>
+              <a:rPr lang="en-US" sz="1200" dirty="0">
+                <a:ea typeface="+mn-lt"/>
+                <a:cs typeface="+mn-lt"/>
+              </a:rPr>
+              <a:t> al </a:t>
+            </a:r>
+            <a:r>
+              <a:rPr lang="en-US" sz="1200" dirty="0" err="1">
+                <a:ea typeface="+mn-lt"/>
+                <a:cs typeface="+mn-lt"/>
+              </a:rPr>
+              <a:t>aumentar</a:t>
+            </a:r>
+            <a:r>
+              <a:rPr lang="en-US" sz="1200" dirty="0">
+                <a:ea typeface="+mn-lt"/>
+                <a:cs typeface="+mn-lt"/>
+              </a:rPr>
+              <a:t> la </a:t>
+            </a:r>
+            <a:r>
+              <a:rPr lang="en-US" sz="1200" dirty="0" err="1">
+                <a:ea typeface="+mn-lt"/>
+                <a:cs typeface="+mn-lt"/>
+              </a:rPr>
+              <a:t>longitud</a:t>
+            </a:r>
+            <a:r>
+              <a:rPr lang="en-US" sz="1200" dirty="0">
+                <a:ea typeface="+mn-lt"/>
+                <a:cs typeface="+mn-lt"/>
+              </a:rPr>
+              <a:t> de </a:t>
+            </a:r>
+            <a:r>
+              <a:rPr lang="en-US" sz="1200" dirty="0" err="1">
+                <a:ea typeface="+mn-lt"/>
+                <a:cs typeface="+mn-lt"/>
+              </a:rPr>
+              <a:t>onda</a:t>
+            </a:r>
+            <a:r>
+              <a:rPr lang="en-US" sz="1200" dirty="0">
+                <a:ea typeface="+mn-lt"/>
+                <a:cs typeface="+mn-lt"/>
+              </a:rPr>
+              <a:t> para ambas </a:t>
+            </a:r>
+            <a:r>
+              <a:rPr lang="en-US" sz="1200" dirty="0" err="1">
+                <a:ea typeface="+mn-lt"/>
+                <a:cs typeface="+mn-lt"/>
+              </a:rPr>
+              <a:t>polarizaciones</a:t>
+            </a:r>
+            <a:r>
+              <a:rPr lang="en-US" sz="1200" dirty="0">
+                <a:ea typeface="+mn-lt"/>
+                <a:cs typeface="+mn-lt"/>
+              </a:rPr>
+              <a:t> (TE y TM) </a:t>
+            </a:r>
+            <a:r>
+              <a:rPr lang="en-US" sz="1200" dirty="0" err="1">
+                <a:ea typeface="+mn-lt"/>
+                <a:cs typeface="+mn-lt"/>
+              </a:rPr>
+              <a:t>en</a:t>
+            </a:r>
+            <a:r>
+              <a:rPr lang="en-US" sz="1200" dirty="0">
+                <a:ea typeface="+mn-lt"/>
+                <a:cs typeface="+mn-lt"/>
+              </a:rPr>
+              <a:t> la </a:t>
+            </a:r>
+            <a:r>
+              <a:rPr lang="en-US" sz="1200" dirty="0" err="1">
+                <a:ea typeface="+mn-lt"/>
+                <a:cs typeface="+mn-lt"/>
+              </a:rPr>
+              <a:t>guía</a:t>
+            </a:r>
+            <a:r>
+              <a:rPr lang="en-US" sz="1200" dirty="0">
+                <a:ea typeface="+mn-lt"/>
+                <a:cs typeface="+mn-lt"/>
+              </a:rPr>
+              <a:t> deep, </a:t>
+            </a:r>
+            <a:r>
+              <a:rPr lang="en-US" sz="1200" dirty="0" err="1">
+                <a:ea typeface="+mn-lt"/>
+                <a:cs typeface="+mn-lt"/>
+              </a:rPr>
+              <a:t>mostrando</a:t>
+            </a:r>
+            <a:r>
+              <a:rPr lang="en-US" sz="1200" dirty="0">
+                <a:ea typeface="+mn-lt"/>
+                <a:cs typeface="+mn-lt"/>
+              </a:rPr>
+              <a:t> un </a:t>
+            </a:r>
+            <a:r>
+              <a:rPr lang="en-US" sz="1200" dirty="0" err="1">
+                <a:ea typeface="+mn-lt"/>
+                <a:cs typeface="+mn-lt"/>
+              </a:rPr>
+              <a:t>comportamiento</a:t>
+            </a:r>
+            <a:r>
+              <a:rPr lang="en-US" sz="1200" dirty="0">
+                <a:ea typeface="+mn-lt"/>
+                <a:cs typeface="+mn-lt"/>
+              </a:rPr>
+              <a:t> suave y </a:t>
+            </a:r>
+            <a:r>
+              <a:rPr lang="en-US" sz="1200" dirty="0" err="1">
+                <a:ea typeface="+mn-lt"/>
+                <a:cs typeface="+mn-lt"/>
+              </a:rPr>
+              <a:t>monótono</a:t>
+            </a:r>
+            <a:r>
+              <a:rPr lang="en-US" sz="1200" dirty="0">
+                <a:ea typeface="+mn-lt"/>
+                <a:cs typeface="+mn-lt"/>
+              </a:rPr>
+              <a:t>, </a:t>
+            </a:r>
+            <a:r>
+              <a:rPr lang="en-US" sz="1200" dirty="0" err="1">
+                <a:ea typeface="+mn-lt"/>
+                <a:cs typeface="+mn-lt"/>
+              </a:rPr>
+              <a:t>siendo</a:t>
+            </a:r>
+            <a:r>
+              <a:rPr lang="en-US" sz="1200" dirty="0">
+                <a:ea typeface="+mn-lt"/>
+                <a:cs typeface="+mn-lt"/>
+              </a:rPr>
+              <a:t> </a:t>
+            </a:r>
+            <a:r>
+              <a:rPr lang="en-US" sz="1200" dirty="0" err="1">
+                <a:ea typeface="+mn-lt"/>
+                <a:cs typeface="+mn-lt"/>
+              </a:rPr>
+              <a:t>siempre</a:t>
+            </a:r>
+            <a:r>
+              <a:rPr lang="en-US" sz="1200" dirty="0">
+                <a:ea typeface="+mn-lt"/>
+                <a:cs typeface="+mn-lt"/>
+              </a:rPr>
+              <a:t> mayor para </a:t>
+            </a:r>
+            <a:r>
+              <a:rPr lang="en-US" sz="1200" dirty="0" err="1">
+                <a:ea typeface="+mn-lt"/>
+                <a:cs typeface="+mn-lt"/>
+              </a:rPr>
+              <a:t>los</a:t>
+            </a:r>
+            <a:r>
+              <a:rPr lang="en-US" sz="1200" dirty="0">
+                <a:ea typeface="+mn-lt"/>
+                <a:cs typeface="+mn-lt"/>
+              </a:rPr>
+              <a:t> </a:t>
+            </a:r>
+            <a:r>
+              <a:rPr lang="en-US" sz="1200" dirty="0" err="1">
+                <a:ea typeface="+mn-lt"/>
+                <a:cs typeface="+mn-lt"/>
+              </a:rPr>
+              <a:t>modos</a:t>
+            </a:r>
+            <a:r>
+              <a:rPr lang="en-US" sz="1200" dirty="0">
+                <a:ea typeface="+mn-lt"/>
+                <a:cs typeface="+mn-lt"/>
+              </a:rPr>
+              <a:t> TE </a:t>
+            </a:r>
+            <a:r>
+              <a:rPr lang="en-US" sz="1200" dirty="0" err="1">
+                <a:ea typeface="+mn-lt"/>
+                <a:cs typeface="+mn-lt"/>
+              </a:rPr>
+              <a:t>que</a:t>
+            </a:r>
+            <a:r>
+              <a:rPr lang="en-US" sz="1200" dirty="0">
+                <a:ea typeface="+mn-lt"/>
+                <a:cs typeface="+mn-lt"/>
+              </a:rPr>
+              <a:t> para </a:t>
+            </a:r>
+            <a:r>
+              <a:rPr lang="en-US" sz="1200" dirty="0" err="1">
+                <a:ea typeface="+mn-lt"/>
+                <a:cs typeface="+mn-lt"/>
+              </a:rPr>
+              <a:t>los</a:t>
+            </a:r>
+            <a:r>
+              <a:rPr lang="en-US" sz="1200" dirty="0">
+                <a:ea typeface="+mn-lt"/>
+                <a:cs typeface="+mn-lt"/>
+              </a:rPr>
+              <a:t> TM. En </a:t>
+            </a:r>
+            <a:r>
+              <a:rPr lang="en-US" sz="1200" dirty="0" err="1">
+                <a:ea typeface="+mn-lt"/>
+                <a:cs typeface="+mn-lt"/>
+              </a:rPr>
+              <a:t>cambio</a:t>
+            </a:r>
+            <a:r>
+              <a:rPr lang="en-US" sz="1200" dirty="0">
+                <a:ea typeface="+mn-lt"/>
+                <a:cs typeface="+mn-lt"/>
+              </a:rPr>
+              <a:t>, </a:t>
+            </a:r>
+            <a:r>
+              <a:rPr lang="en-US" sz="1200" dirty="0" err="1">
+                <a:ea typeface="+mn-lt"/>
+                <a:cs typeface="+mn-lt"/>
+              </a:rPr>
+              <a:t>en</a:t>
+            </a:r>
+            <a:r>
+              <a:rPr lang="en-US" sz="1200" dirty="0">
+                <a:ea typeface="+mn-lt"/>
+                <a:cs typeface="+mn-lt"/>
+              </a:rPr>
+              <a:t> la </a:t>
+            </a:r>
+            <a:r>
+              <a:rPr lang="en-US" sz="1200" dirty="0" err="1">
+                <a:ea typeface="+mn-lt"/>
+                <a:cs typeface="+mn-lt"/>
+              </a:rPr>
+              <a:t>guía</a:t>
+            </a:r>
+            <a:r>
+              <a:rPr lang="en-US" sz="1200" dirty="0">
+                <a:ea typeface="+mn-lt"/>
+                <a:cs typeface="+mn-lt"/>
+              </a:rPr>
+              <a:t> shallow </a:t>
+            </a:r>
+            <a:r>
+              <a:rPr lang="en-US" sz="1200" dirty="0" err="1">
+                <a:ea typeface="+mn-lt"/>
+                <a:cs typeface="+mn-lt"/>
+              </a:rPr>
+              <a:t>el</a:t>
+            </a:r>
+            <a:r>
+              <a:rPr lang="en-US" sz="1200" dirty="0">
+                <a:ea typeface="+mn-lt"/>
+                <a:cs typeface="+mn-lt"/>
+              </a:rPr>
+              <a:t> </a:t>
+            </a:r>
+            <a:r>
+              <a:rPr lang="en-US" sz="1200" dirty="0" err="1">
+                <a:ea typeface="+mn-lt"/>
+                <a:cs typeface="+mn-lt"/>
+              </a:rPr>
+              <a:t>comportamiento</a:t>
+            </a:r>
+            <a:r>
+              <a:rPr lang="en-US" sz="1200" dirty="0">
+                <a:ea typeface="+mn-lt"/>
+                <a:cs typeface="+mn-lt"/>
+              </a:rPr>
+              <a:t> es </a:t>
+            </a:r>
+            <a:r>
+              <a:rPr lang="en-US" sz="1200" dirty="0" err="1">
+                <a:ea typeface="+mn-lt"/>
+                <a:cs typeface="+mn-lt"/>
+              </a:rPr>
+              <a:t>muy</a:t>
+            </a:r>
+            <a:r>
+              <a:rPr lang="en-US" sz="1200" dirty="0">
+                <a:ea typeface="+mn-lt"/>
+                <a:cs typeface="+mn-lt"/>
+              </a:rPr>
+              <a:t> </a:t>
+            </a:r>
+            <a:r>
+              <a:rPr lang="en-US" sz="1200" dirty="0" err="1">
+                <a:ea typeface="+mn-lt"/>
+                <a:cs typeface="+mn-lt"/>
+              </a:rPr>
+              <a:t>distinto</a:t>
+            </a:r>
+            <a:r>
+              <a:rPr lang="en-US" sz="1200" dirty="0">
+                <a:ea typeface="+mn-lt"/>
+                <a:cs typeface="+mn-lt"/>
+              </a:rPr>
+              <a:t>: </a:t>
+            </a:r>
+            <a:r>
+              <a:rPr lang="en-US" sz="1200" dirty="0" err="1">
+                <a:ea typeface="+mn-lt"/>
+                <a:cs typeface="+mn-lt"/>
+              </a:rPr>
+              <a:t>los</a:t>
+            </a:r>
+            <a:r>
+              <a:rPr lang="en-US" sz="1200" dirty="0">
+                <a:ea typeface="+mn-lt"/>
+                <a:cs typeface="+mn-lt"/>
+              </a:rPr>
+              <a:t> </a:t>
+            </a:r>
+            <a:r>
+              <a:rPr lang="en-US" sz="1200" dirty="0" err="1">
+                <a:ea typeface="+mn-lt"/>
+                <a:cs typeface="+mn-lt"/>
+              </a:rPr>
+              <a:t>modos</a:t>
+            </a:r>
+            <a:r>
+              <a:rPr lang="en-US" sz="1200" dirty="0">
+                <a:ea typeface="+mn-lt"/>
+                <a:cs typeface="+mn-lt"/>
+              </a:rPr>
+              <a:t> TE se </a:t>
+            </a:r>
+            <a:r>
+              <a:rPr lang="en-US" sz="1200" dirty="0" err="1">
+                <a:ea typeface="+mn-lt"/>
+                <a:cs typeface="+mn-lt"/>
+              </a:rPr>
+              <a:t>mantienen</a:t>
+            </a:r>
+            <a:r>
+              <a:rPr lang="en-US" sz="1200" dirty="0">
+                <a:ea typeface="+mn-lt"/>
+                <a:cs typeface="+mn-lt"/>
+              </a:rPr>
+              <a:t> </a:t>
+            </a:r>
+            <a:r>
+              <a:rPr lang="en-US" sz="1200" dirty="0" err="1">
+                <a:ea typeface="+mn-lt"/>
+                <a:cs typeface="+mn-lt"/>
+              </a:rPr>
+              <a:t>prácticamente</a:t>
+            </a:r>
+            <a:r>
+              <a:rPr lang="en-US" sz="1200" dirty="0">
+                <a:ea typeface="+mn-lt"/>
+                <a:cs typeface="+mn-lt"/>
+              </a:rPr>
+              <a:t> </a:t>
+            </a:r>
+            <a:r>
+              <a:rPr lang="en-US" sz="1200" dirty="0" err="1">
+                <a:ea typeface="+mn-lt"/>
+                <a:cs typeface="+mn-lt"/>
+              </a:rPr>
+              <a:t>constantes</a:t>
+            </a:r>
+            <a:r>
+              <a:rPr lang="en-US" sz="1200" dirty="0">
+                <a:ea typeface="+mn-lt"/>
+                <a:cs typeface="+mn-lt"/>
+              </a:rPr>
+              <a:t> con la </a:t>
+            </a:r>
+            <a:r>
+              <a:rPr lang="en-US" sz="1200" dirty="0" err="1">
+                <a:ea typeface="+mn-lt"/>
+                <a:cs typeface="+mn-lt"/>
+              </a:rPr>
+              <a:t>longitud</a:t>
+            </a:r>
+            <a:r>
+              <a:rPr lang="en-US" sz="1200" dirty="0">
+                <a:ea typeface="+mn-lt"/>
+                <a:cs typeface="+mn-lt"/>
+              </a:rPr>
+              <a:t> de </a:t>
+            </a:r>
+            <a:r>
+              <a:rPr lang="en-US" sz="1200" dirty="0" err="1">
+                <a:ea typeface="+mn-lt"/>
+                <a:cs typeface="+mn-lt"/>
+              </a:rPr>
+              <a:t>onda</a:t>
+            </a:r>
+            <a:r>
+              <a:rPr lang="en-US" sz="1200" dirty="0">
+                <a:ea typeface="+mn-lt"/>
+                <a:cs typeface="+mn-lt"/>
+              </a:rPr>
+              <a:t>, lo </a:t>
+            </a:r>
+            <a:r>
+              <a:rPr lang="en-US" sz="1200" dirty="0" err="1">
+                <a:ea typeface="+mn-lt"/>
+                <a:cs typeface="+mn-lt"/>
+              </a:rPr>
+              <a:t>que</a:t>
+            </a:r>
+            <a:r>
+              <a:rPr lang="en-US" sz="1200" dirty="0">
+                <a:ea typeface="+mn-lt"/>
+                <a:cs typeface="+mn-lt"/>
+              </a:rPr>
+              <a:t> indica </a:t>
+            </a:r>
+            <a:r>
+              <a:rPr lang="en-US" sz="1200" dirty="0" err="1">
+                <a:ea typeface="+mn-lt"/>
+                <a:cs typeface="+mn-lt"/>
+              </a:rPr>
+              <a:t>una</a:t>
+            </a:r>
+            <a:r>
+              <a:rPr lang="en-US" sz="1200" dirty="0">
+                <a:ea typeface="+mn-lt"/>
+                <a:cs typeface="+mn-lt"/>
+              </a:rPr>
+              <a:t> </a:t>
+            </a:r>
+            <a:r>
+              <a:rPr lang="en-US" sz="1200" dirty="0" err="1">
+                <a:ea typeface="+mn-lt"/>
+                <a:cs typeface="+mn-lt"/>
+              </a:rPr>
+              <a:t>débil</a:t>
+            </a:r>
+            <a:r>
+              <a:rPr lang="en-US" sz="1200" dirty="0">
+                <a:ea typeface="+mn-lt"/>
+                <a:cs typeface="+mn-lt"/>
+              </a:rPr>
+              <a:t> </a:t>
+            </a:r>
+            <a:r>
+              <a:rPr lang="en-US" sz="1200" dirty="0" err="1">
+                <a:ea typeface="+mn-lt"/>
+                <a:cs typeface="+mn-lt"/>
+              </a:rPr>
+              <a:t>dependencia</a:t>
+            </a:r>
+            <a:r>
+              <a:rPr lang="en-US" sz="1200" dirty="0">
+                <a:ea typeface="+mn-lt"/>
+                <a:cs typeface="+mn-lt"/>
+              </a:rPr>
+              <a:t>, </a:t>
+            </a:r>
+            <a:r>
+              <a:rPr lang="en-US" sz="1200" dirty="0" err="1">
+                <a:ea typeface="+mn-lt"/>
+                <a:cs typeface="+mn-lt"/>
+              </a:rPr>
+              <a:t>mientras</a:t>
+            </a:r>
+            <a:r>
+              <a:rPr lang="en-US" sz="1200" dirty="0">
+                <a:ea typeface="+mn-lt"/>
+                <a:cs typeface="+mn-lt"/>
+              </a:rPr>
+              <a:t> </a:t>
+            </a:r>
+            <a:r>
+              <a:rPr lang="en-US" sz="1200" dirty="0" err="1">
+                <a:ea typeface="+mn-lt"/>
+                <a:cs typeface="+mn-lt"/>
+              </a:rPr>
+              <a:t>que</a:t>
+            </a:r>
+            <a:r>
+              <a:rPr lang="en-US" sz="1200" dirty="0">
+                <a:ea typeface="+mn-lt"/>
+                <a:cs typeface="+mn-lt"/>
+              </a:rPr>
+              <a:t> </a:t>
+            </a:r>
+            <a:r>
+              <a:rPr lang="en-US" sz="1200" dirty="0" err="1">
+                <a:ea typeface="+mn-lt"/>
+                <a:cs typeface="+mn-lt"/>
+              </a:rPr>
+              <a:t>los</a:t>
+            </a:r>
+            <a:r>
+              <a:rPr lang="en-US" sz="1200" dirty="0">
+                <a:ea typeface="+mn-lt"/>
+                <a:cs typeface="+mn-lt"/>
+              </a:rPr>
+              <a:t> </a:t>
+            </a:r>
+            <a:r>
+              <a:rPr lang="en-US" sz="1200" dirty="0" err="1">
+                <a:ea typeface="+mn-lt"/>
+                <a:cs typeface="+mn-lt"/>
+              </a:rPr>
+              <a:t>modos</a:t>
+            </a:r>
+            <a:r>
+              <a:rPr lang="en-US" sz="1200" dirty="0">
+                <a:ea typeface="+mn-lt"/>
+                <a:cs typeface="+mn-lt"/>
+              </a:rPr>
+              <a:t> TM </a:t>
+            </a:r>
+            <a:r>
+              <a:rPr lang="en-US" sz="1200" dirty="0" err="1">
+                <a:ea typeface="+mn-lt"/>
+                <a:cs typeface="+mn-lt"/>
+              </a:rPr>
+              <a:t>presentan</a:t>
+            </a:r>
+            <a:r>
+              <a:rPr lang="en-US" sz="1200" dirty="0">
+                <a:ea typeface="+mn-lt"/>
+                <a:cs typeface="+mn-lt"/>
+              </a:rPr>
+              <a:t> </a:t>
+            </a:r>
+            <a:r>
+              <a:rPr lang="en-US" sz="1200" dirty="0" err="1">
+                <a:ea typeface="+mn-lt"/>
+                <a:cs typeface="+mn-lt"/>
+              </a:rPr>
+              <a:t>valores</a:t>
+            </a:r>
+            <a:r>
+              <a:rPr lang="en-US" sz="1200" dirty="0">
+                <a:ea typeface="+mn-lt"/>
+                <a:cs typeface="+mn-lt"/>
+              </a:rPr>
+              <a:t> de Lπ  </a:t>
+            </a:r>
+            <a:r>
+              <a:rPr lang="en-US" sz="1200" dirty="0" err="1">
+                <a:ea typeface="+mn-lt"/>
+                <a:cs typeface="+mn-lt"/>
+              </a:rPr>
+              <a:t>mucho</a:t>
+            </a:r>
+            <a:r>
+              <a:rPr lang="en-US" sz="1200" dirty="0">
+                <a:ea typeface="+mn-lt"/>
+                <a:cs typeface="+mn-lt"/>
+              </a:rPr>
+              <a:t> </a:t>
+            </a:r>
+            <a:r>
+              <a:rPr lang="en-US" sz="1200" dirty="0" err="1">
+                <a:ea typeface="+mn-lt"/>
+                <a:cs typeface="+mn-lt"/>
+              </a:rPr>
+              <a:t>más</a:t>
+            </a:r>
+            <a:r>
+              <a:rPr lang="en-US" sz="1200" dirty="0">
+                <a:ea typeface="+mn-lt"/>
+                <a:cs typeface="+mn-lt"/>
+              </a:rPr>
+              <a:t> altos y </a:t>
+            </a:r>
+            <a:r>
+              <a:rPr lang="en-US" sz="1200" dirty="0" err="1">
+                <a:ea typeface="+mn-lt"/>
+                <a:cs typeface="+mn-lt"/>
+              </a:rPr>
+              <a:t>una</a:t>
+            </a:r>
+            <a:r>
+              <a:rPr lang="en-US" sz="1200" dirty="0">
+                <a:ea typeface="+mn-lt"/>
+                <a:cs typeface="+mn-lt"/>
+              </a:rPr>
+              <a:t> </a:t>
+            </a:r>
+            <a:r>
+              <a:rPr lang="en-US" sz="1200" dirty="0" err="1">
+                <a:ea typeface="+mn-lt"/>
+                <a:cs typeface="+mn-lt"/>
+              </a:rPr>
+              <a:t>tendencia</a:t>
+            </a:r>
+            <a:r>
+              <a:rPr lang="en-US" sz="1200" dirty="0">
+                <a:ea typeface="+mn-lt"/>
+                <a:cs typeface="+mn-lt"/>
+              </a:rPr>
+              <a:t> no </a:t>
+            </a:r>
+            <a:r>
+              <a:rPr lang="en-US" sz="1200" dirty="0" err="1">
+                <a:ea typeface="+mn-lt"/>
+                <a:cs typeface="+mn-lt"/>
+              </a:rPr>
+              <a:t>monótona</a:t>
+            </a:r>
+            <a:r>
+              <a:rPr lang="en-US" sz="1200" dirty="0">
+                <a:ea typeface="+mn-lt"/>
+                <a:cs typeface="+mn-lt"/>
+              </a:rPr>
+              <a:t>, con </a:t>
+            </a:r>
+            <a:r>
+              <a:rPr lang="en-US" sz="1200" dirty="0" err="1">
+                <a:ea typeface="+mn-lt"/>
+                <a:cs typeface="+mn-lt"/>
+              </a:rPr>
+              <a:t>una</a:t>
+            </a:r>
+            <a:r>
+              <a:rPr lang="en-US" sz="1200" dirty="0">
+                <a:ea typeface="+mn-lt"/>
+                <a:cs typeface="+mn-lt"/>
+              </a:rPr>
+              <a:t> </a:t>
+            </a:r>
+            <a:r>
+              <a:rPr lang="en-US" sz="1200" dirty="0" err="1">
+                <a:ea typeface="+mn-lt"/>
+                <a:cs typeface="+mn-lt"/>
+              </a:rPr>
+              <a:t>fuerte</a:t>
+            </a:r>
+            <a:r>
+              <a:rPr lang="en-US" sz="1200" dirty="0">
+                <a:ea typeface="+mn-lt"/>
+                <a:cs typeface="+mn-lt"/>
+              </a:rPr>
+              <a:t> </a:t>
+            </a:r>
+            <a:r>
+              <a:rPr lang="en-US" sz="1200" dirty="0" err="1">
+                <a:ea typeface="+mn-lt"/>
+                <a:cs typeface="+mn-lt"/>
+              </a:rPr>
+              <a:t>disminución</a:t>
+            </a:r>
+            <a:r>
+              <a:rPr lang="en-US" sz="1200" dirty="0">
+                <a:ea typeface="+mn-lt"/>
+                <a:cs typeface="+mn-lt"/>
+              </a:rPr>
+              <a:t> </a:t>
+            </a:r>
+            <a:r>
+              <a:rPr lang="en-US" sz="1200" dirty="0" err="1">
+                <a:ea typeface="+mn-lt"/>
+                <a:cs typeface="+mn-lt"/>
+              </a:rPr>
+              <a:t>seguida</a:t>
+            </a:r>
+            <a:r>
+              <a:rPr lang="en-US" sz="1200" dirty="0">
+                <a:ea typeface="+mn-lt"/>
+                <a:cs typeface="+mn-lt"/>
+              </a:rPr>
+              <a:t> de un ligero </a:t>
+            </a:r>
+            <a:r>
+              <a:rPr lang="en-US" sz="1200" dirty="0" err="1">
+                <a:ea typeface="+mn-lt"/>
+                <a:cs typeface="+mn-lt"/>
+              </a:rPr>
+              <a:t>aumento</a:t>
+            </a:r>
+            <a:r>
+              <a:rPr lang="en-US" sz="1200" dirty="0">
+                <a:ea typeface="+mn-lt"/>
+                <a:cs typeface="+mn-lt"/>
+              </a:rPr>
+              <a:t>. Esto pone de </a:t>
+            </a:r>
+            <a:r>
+              <a:rPr lang="en-US" sz="1200" dirty="0" err="1">
+                <a:ea typeface="+mn-lt"/>
+                <a:cs typeface="+mn-lt"/>
+              </a:rPr>
+              <a:t>manifiesto</a:t>
+            </a:r>
+            <a:r>
+              <a:rPr lang="en-US" sz="1200" dirty="0">
+                <a:ea typeface="+mn-lt"/>
+                <a:cs typeface="+mn-lt"/>
+              </a:rPr>
+              <a:t> </a:t>
+            </a:r>
+            <a:r>
+              <a:rPr lang="en-US" sz="1200" dirty="0" err="1">
+                <a:ea typeface="+mn-lt"/>
+                <a:cs typeface="+mn-lt"/>
+              </a:rPr>
+              <a:t>que</a:t>
+            </a:r>
+            <a:r>
+              <a:rPr lang="en-US" sz="1200" dirty="0">
+                <a:ea typeface="+mn-lt"/>
+                <a:cs typeface="+mn-lt"/>
+              </a:rPr>
+              <a:t> las </a:t>
+            </a:r>
+            <a:r>
+              <a:rPr lang="en-US" sz="1200" dirty="0" err="1">
+                <a:ea typeface="+mn-lt"/>
+                <a:cs typeface="+mn-lt"/>
+              </a:rPr>
+              <a:t>estructuras</a:t>
+            </a:r>
+            <a:r>
+              <a:rPr lang="en-US" sz="1200" dirty="0">
+                <a:ea typeface="+mn-lt"/>
+                <a:cs typeface="+mn-lt"/>
+              </a:rPr>
+              <a:t> shallow </a:t>
+            </a:r>
+            <a:r>
+              <a:rPr lang="en-US" sz="1200" dirty="0" err="1">
+                <a:ea typeface="+mn-lt"/>
+                <a:cs typeface="+mn-lt"/>
+              </a:rPr>
+              <a:t>introducen</a:t>
+            </a:r>
+            <a:r>
+              <a:rPr lang="en-US" sz="1200" dirty="0">
+                <a:ea typeface="+mn-lt"/>
+                <a:cs typeface="+mn-lt"/>
+              </a:rPr>
+              <a:t> </a:t>
+            </a:r>
+            <a:r>
+              <a:rPr lang="en-US" sz="1200" dirty="0" err="1">
+                <a:ea typeface="+mn-lt"/>
+                <a:cs typeface="+mn-lt"/>
+              </a:rPr>
+              <a:t>una</a:t>
+            </a:r>
+            <a:r>
+              <a:rPr lang="en-US" sz="1200" dirty="0">
+                <a:ea typeface="+mn-lt"/>
+                <a:cs typeface="+mn-lt"/>
+              </a:rPr>
+              <a:t> mayor </a:t>
+            </a:r>
+            <a:r>
+              <a:rPr lang="en-US" sz="1200" dirty="0" err="1">
+                <a:ea typeface="+mn-lt"/>
+                <a:cs typeface="+mn-lt"/>
+              </a:rPr>
+              <a:t>dependencia</a:t>
+            </a:r>
+            <a:r>
+              <a:rPr lang="en-US" sz="1200" dirty="0">
+                <a:ea typeface="+mn-lt"/>
+                <a:cs typeface="+mn-lt"/>
+              </a:rPr>
+              <a:t> con la </a:t>
+            </a:r>
+            <a:r>
+              <a:rPr lang="en-US" sz="1200" dirty="0" err="1">
+                <a:ea typeface="+mn-lt"/>
+                <a:cs typeface="+mn-lt"/>
+              </a:rPr>
+              <a:t>polarización</a:t>
+            </a:r>
+            <a:r>
+              <a:rPr lang="en-US" sz="1200" dirty="0">
+                <a:ea typeface="+mn-lt"/>
+                <a:cs typeface="+mn-lt"/>
+              </a:rPr>
+              <a:t> y un </a:t>
+            </a:r>
+            <a:r>
+              <a:rPr lang="en-US" sz="1200" dirty="0" err="1">
+                <a:ea typeface="+mn-lt"/>
+                <a:cs typeface="+mn-lt"/>
+              </a:rPr>
+              <a:t>comportamiento</a:t>
+            </a:r>
+            <a:r>
+              <a:rPr lang="en-US" sz="1200" dirty="0">
+                <a:ea typeface="+mn-lt"/>
+                <a:cs typeface="+mn-lt"/>
+              </a:rPr>
+              <a:t> </a:t>
+            </a:r>
+            <a:r>
+              <a:rPr lang="en-US" sz="1200" dirty="0" err="1">
+                <a:ea typeface="+mn-lt"/>
+                <a:cs typeface="+mn-lt"/>
+              </a:rPr>
+              <a:t>menos</a:t>
+            </a:r>
+            <a:r>
+              <a:rPr lang="en-US" sz="1200" dirty="0">
+                <a:ea typeface="+mn-lt"/>
+                <a:cs typeface="+mn-lt"/>
+              </a:rPr>
+              <a:t> </a:t>
+            </a:r>
+            <a:r>
+              <a:rPr lang="en-US" sz="1200" dirty="0" err="1">
+                <a:ea typeface="+mn-lt"/>
+                <a:cs typeface="+mn-lt"/>
+              </a:rPr>
+              <a:t>estable</a:t>
+            </a:r>
+            <a:r>
+              <a:rPr lang="en-US" sz="1200" dirty="0">
+                <a:ea typeface="+mn-lt"/>
+                <a:cs typeface="+mn-lt"/>
+              </a:rPr>
+              <a:t>, </a:t>
+            </a:r>
+            <a:r>
+              <a:rPr lang="en-US" sz="1200" dirty="0" err="1">
+                <a:ea typeface="+mn-lt"/>
+                <a:cs typeface="+mn-lt"/>
+              </a:rPr>
+              <a:t>especialmente</a:t>
+            </a:r>
+            <a:r>
+              <a:rPr lang="en-US" sz="1200" dirty="0">
+                <a:ea typeface="+mn-lt"/>
+                <a:cs typeface="+mn-lt"/>
+              </a:rPr>
+              <a:t> para </a:t>
+            </a:r>
+            <a:r>
+              <a:rPr lang="en-US" sz="1200" dirty="0" err="1">
+                <a:ea typeface="+mn-lt"/>
+                <a:cs typeface="+mn-lt"/>
+              </a:rPr>
+              <a:t>los</a:t>
+            </a:r>
+            <a:r>
+              <a:rPr lang="en-US" sz="1200" dirty="0">
+                <a:ea typeface="+mn-lt"/>
+                <a:cs typeface="+mn-lt"/>
+              </a:rPr>
+              <a:t> </a:t>
+            </a:r>
+            <a:r>
+              <a:rPr lang="en-US" sz="1200" dirty="0" err="1">
+                <a:ea typeface="+mn-lt"/>
+                <a:cs typeface="+mn-lt"/>
+              </a:rPr>
+              <a:t>modos</a:t>
+            </a:r>
+            <a:r>
+              <a:rPr lang="en-US" sz="1200" dirty="0">
+                <a:ea typeface="+mn-lt"/>
+                <a:cs typeface="+mn-lt"/>
+              </a:rPr>
+              <a:t> TM, </a:t>
+            </a:r>
+            <a:r>
+              <a:rPr lang="en-US" sz="1200" dirty="0" err="1">
+                <a:ea typeface="+mn-lt"/>
+                <a:cs typeface="+mn-lt"/>
+              </a:rPr>
+              <a:t>mientras</a:t>
+            </a:r>
+            <a:r>
+              <a:rPr lang="en-US" sz="1200" dirty="0">
+                <a:ea typeface="+mn-lt"/>
+                <a:cs typeface="+mn-lt"/>
+              </a:rPr>
+              <a:t> </a:t>
+            </a:r>
+            <a:r>
+              <a:rPr lang="en-US" sz="1200" dirty="0" err="1">
+                <a:ea typeface="+mn-lt"/>
+                <a:cs typeface="+mn-lt"/>
+              </a:rPr>
+              <a:t>que</a:t>
+            </a:r>
+            <a:r>
+              <a:rPr lang="en-US" sz="1200" dirty="0">
+                <a:ea typeface="+mn-lt"/>
+                <a:cs typeface="+mn-lt"/>
+              </a:rPr>
+              <a:t> las </a:t>
+            </a:r>
+            <a:r>
+              <a:rPr lang="en-US" sz="1200" dirty="0" err="1">
+                <a:ea typeface="+mn-lt"/>
+                <a:cs typeface="+mn-lt"/>
+              </a:rPr>
+              <a:t>guías</a:t>
+            </a:r>
+            <a:r>
+              <a:rPr lang="en-US" sz="1200" dirty="0">
+                <a:ea typeface="+mn-lt"/>
+                <a:cs typeface="+mn-lt"/>
+              </a:rPr>
+              <a:t> deep </a:t>
+            </a:r>
+            <a:r>
+              <a:rPr lang="en-US" sz="1200" dirty="0" err="1">
+                <a:ea typeface="+mn-lt"/>
+                <a:cs typeface="+mn-lt"/>
+              </a:rPr>
+              <a:t>ofrecen</a:t>
+            </a:r>
+            <a:r>
+              <a:rPr lang="en-US" sz="1200" dirty="0">
+                <a:ea typeface="+mn-lt"/>
+                <a:cs typeface="+mn-lt"/>
+              </a:rPr>
+              <a:t> un </a:t>
+            </a:r>
+            <a:r>
+              <a:rPr lang="en-US" sz="1200" dirty="0" err="1">
+                <a:ea typeface="+mn-lt"/>
+                <a:cs typeface="+mn-lt"/>
+              </a:rPr>
+              <a:t>funcionamiento</a:t>
+            </a:r>
+            <a:r>
+              <a:rPr lang="en-US" sz="1200" dirty="0">
+                <a:ea typeface="+mn-lt"/>
+                <a:cs typeface="+mn-lt"/>
+              </a:rPr>
+              <a:t> </a:t>
+            </a:r>
+            <a:r>
+              <a:rPr lang="en-US" sz="1200" dirty="0" err="1">
+                <a:ea typeface="+mn-lt"/>
+                <a:cs typeface="+mn-lt"/>
+              </a:rPr>
+              <a:t>más</a:t>
+            </a:r>
+            <a:r>
+              <a:rPr lang="en-US" sz="1200" dirty="0">
+                <a:ea typeface="+mn-lt"/>
+                <a:cs typeface="+mn-lt"/>
+              </a:rPr>
+              <a:t> </a:t>
+            </a:r>
+            <a:r>
+              <a:rPr lang="en-US" sz="1200" dirty="0" err="1">
+                <a:ea typeface="+mn-lt"/>
+                <a:cs typeface="+mn-lt"/>
+              </a:rPr>
+              <a:t>predecible</a:t>
+            </a:r>
+            <a:r>
+              <a:rPr lang="en-US" sz="1200" dirty="0">
+                <a:ea typeface="+mn-lt"/>
+                <a:cs typeface="+mn-lt"/>
+              </a:rPr>
+              <a:t> y </a:t>
+            </a:r>
+            <a:r>
+              <a:rPr lang="en-US" sz="1200" dirty="0" err="1">
+                <a:ea typeface="+mn-lt"/>
+                <a:cs typeface="+mn-lt"/>
+              </a:rPr>
+              <a:t>uniforme</a:t>
+            </a:r>
+            <a:r>
+              <a:rPr lang="en-US" sz="1200" dirty="0">
+                <a:ea typeface="+mn-lt"/>
+                <a:cs typeface="+mn-lt"/>
+              </a:rPr>
+              <a:t>.</a:t>
+            </a:r>
+            <a:endParaRPr lang="es-ES" dirty="0"/>
           </a:p>
           <a:p>
             <a:pPr algn="just"/>
@@ -12559,42 +13877,6 @@
           <a:p>
             <a:pPr algn="ctr"/>
             <a:endParaRPr lang="en-US"/>
-          </a:p>
-        </p:txBody>
-      </p:sp>
-      <p:sp>
-        <p:nvSpPr>
-          <p:cNvPr id="7" name="CuadroTexto 6">
-            <a:extLst>
-              <a:ext uri="{FF2B5EF4-FFF2-40B4-BE49-F238E27FC236}">
-                <a16:creationId xmlns:a16="http://schemas.microsoft.com/office/drawing/2014/main" id="{5F16E403-DF61-C9A0-D57F-2E61BEFA8887}"/>
-              </a:ext>
-            </a:extLst>
-          </p:cNvPr>
-          <p:cNvSpPr txBox="1"/>
-          <p:nvPr/>
-        </p:nvSpPr>
-        <p:spPr>
-          <a:xfrm>
-            <a:off x="6331152" y="4342178"/>
-            <a:ext cx="2269787" cy="369332"/>
-          </a:xfrm>
-          <a:prstGeom prst="rect">
-            <a:avLst/>
-          </a:prstGeom>
-          <a:noFill/>
-        </p:spPr>
-        <p:txBody>
-          <a:bodyPr wrap="square">
-            <a:spAutoFit/>
-          </a:bodyPr>
-          <a:lstStyle/>
-          <a:p>
-            <a:r>
-              <a:rPr lang="en-US" dirty="0"/>
-              <a:t>slab = 150nm</a:t>
-            </a:r>
-            <a:endParaRPr lang="es-ES" dirty="0"/>
           </a:p>
         </p:txBody>
       </p:sp>
@@ -12878,6 +14160,66 @@
           </p:sp>
         </mc:Fallback>
       </mc:AlternateContent>
+      <p:pic>
+        <p:nvPicPr>
+          <p:cNvPr id="4" name="Imagen 3" descr="Gráfico, Gráfico de líneas&#10;&#10;El contenido generado por IA puede ser incorrecto.">
+            <a:extLst>
+              <a:ext uri="{FF2B5EF4-FFF2-40B4-BE49-F238E27FC236}">
+                <a16:creationId xmlns:a16="http://schemas.microsoft.com/office/drawing/2014/main" id="{29F93638-3D8C-529F-9BC5-B08FBF4BD57A}"/>
+              </a:ext>
+            </a:extLst>
+          </p:cNvPr>
+          <p:cNvPicPr>
+            <a:picLocks noChangeAspect="1"/>
+          </p:cNvPicPr>
+          <p:nvPr/>
+        </p:nvPicPr>
+        <p:blipFill>
+          <a:blip r:embed="rId7"/>
+          <a:stretch>
+            <a:fillRect/>
+          </a:stretch>
+        </p:blipFill>
+        <p:spPr>
+          <a:xfrm>
+            <a:off x="1397610" y="1533158"/>
+            <a:ext cx="3904518" cy="3141054"/>
+          </a:xfrm>
+          <a:prstGeom prst="rect">
+            <a:avLst/>
+          </a:prstGeom>
+        </p:spPr>
+      </p:pic>
+      <p:pic>
+        <p:nvPicPr>
+          <p:cNvPr id="10" name="Imagen 9" descr="Gráfico, Gráfico de líneas&#10;&#10;El contenido generado por IA puede ser incorrecto.">
+            <a:extLst>
+              <a:ext uri="{FF2B5EF4-FFF2-40B4-BE49-F238E27FC236}">
+                <a16:creationId xmlns:a16="http://schemas.microsoft.com/office/drawing/2014/main" id="{5DF70BF3-A619-6499-599C-AA996AB171D8}"/>
+              </a:ext>
+            </a:extLst>
+          </p:cNvPr>
+          <p:cNvPicPr>
+            <a:picLocks noChangeAspect="1"/>
+          </p:cNvPicPr>
+          <p:nvPr/>
+        </p:nvPicPr>
+        <p:blipFill>
+          <a:blip r:embed="rId8"/>
+          <a:stretch>
+            <a:fillRect/>
+          </a:stretch>
+        </p:blipFill>
+        <p:spPr>
+          <a:xfrm>
+            <a:off x="7112609" y="1554579"/>
+            <a:ext cx="3904518" cy="3098209"/>
+          </a:xfrm>
+          <a:prstGeom prst="rect">
+            <a:avLst/>
+          </a:prstGeom>
+        </p:spPr>
+      </p:pic>
     </p:spTree>
     <p:extLst>
       <p:ext uri="{BB962C8B-B14F-4D97-AF65-F5344CB8AC3E}">
@@ -17437,8 +18779,8 @@
         </p:blipFill>
         <p:spPr>
           <a:xfrm>
-            <a:off x="686279" y="1284594"/>
-            <a:ext cx="4896332" cy="3417956"/>
+            <a:off x="750756" y="979794"/>
+            <a:ext cx="3331303" cy="2310126"/>
           </a:xfrm>
           <a:prstGeom prst="rect">
             <a:avLst/>
@@ -17459,7 +18801,7 @@
         </p:nvSpPr>
         <p:spPr>
           <a:xfrm>
-            <a:off x="6095902" y="1717055"/>
+            <a:off x="5087717" y="2027717"/>
             <a:ext cx="2307788" cy="2800767"/>
           </a:xfrm>
           <a:prstGeom prst="rect">
@@ -17705,7 +19047,7 @@
         </p:nvCxnSpPr>
         <p:spPr>
           <a:xfrm>
-            <a:off x="8515352" y="1672658"/>
+            <a:off x="7507167" y="1983320"/>
             <a:ext cx="16006" cy="2865127"/>
           </a:xfrm>
           <a:prstGeom prst="straightConnector1">
@@ -17746,7 +19088,7 @@
         </p:nvSpPr>
         <p:spPr>
           <a:xfrm>
-            <a:off x="8859487" y="1719074"/>
+            <a:off x="7851302" y="2029736"/>
             <a:ext cx="2825112" cy="2554545"/>
           </a:xfrm>
           <a:prstGeom prst="rect">
@@ -17937,6 +19279,125 @@
               </a:rPr>
               <a:t>acoplamiento entre guías.</a:t>
             </a:r>
+          </a:p>
+        </p:txBody>
+      </p:sp>
+      <p:pic>
+        <p:nvPicPr>
+          <p:cNvPr id="7" name="Imagen 6" descr="Gráfico, Gráfico de barras&#10;&#10;El contenido generado por IA puede ser incorrecto.">
+            <a:extLst>
+              <a:ext uri="{FF2B5EF4-FFF2-40B4-BE49-F238E27FC236}">
+                <a16:creationId xmlns:a16="http://schemas.microsoft.com/office/drawing/2014/main" id="{B3D4273C-954E-0DAE-F54C-1B6951766132}"/>
+              </a:ext>
+            </a:extLst>
+          </p:cNvPr>
+          <p:cNvPicPr>
+            <a:picLocks noChangeAspect="1"/>
+          </p:cNvPicPr>
+          <p:nvPr/>
+        </p:nvPicPr>
+        <p:blipFill>
+          <a:blip r:embed="rId5"/>
+          <a:stretch>
+            <a:fillRect/>
+          </a:stretch>
+        </p:blipFill>
+        <p:spPr>
+          <a:xfrm>
+            <a:off x="610078" y="3546989"/>
+            <a:ext cx="3471980" cy="2415948"/>
+          </a:xfrm>
+          <a:prstGeom prst="rect">
+            <a:avLst/>
+          </a:prstGeom>
+        </p:spPr>
+      </p:pic>
+      <p:sp>
+        <p:nvSpPr>
+          <p:cNvPr id="8" name="CuadroTexto 7">
+            <a:extLst>
+              <a:ext uri="{FF2B5EF4-FFF2-40B4-BE49-F238E27FC236}">
+                <a16:creationId xmlns:a16="http://schemas.microsoft.com/office/drawing/2014/main" id="{031F3AC3-D489-9504-9C38-41BD05D04BD2}"/>
+              </a:ext>
+            </a:extLst>
+          </p:cNvPr>
+          <p:cNvSpPr txBox="1"/>
+          <p:nvPr/>
+        </p:nvSpPr>
+        <p:spPr>
+          <a:xfrm>
+            <a:off x="1181717" y="1004102"/>
+            <a:ext cx="802232" cy="369332"/>
+          </a:xfrm>
+          <a:prstGeom prst="rect">
+            <a:avLst/>
+          </a:prstGeom>
+          <a:noFill/>
+        </p:spPr>
+        <p:txBody>
+          <a:bodyPr rot="0" spcFirstLastPara="0" vertOverflow="overflow" horzOverflow="overflow" vert="horz" wrap="square" lIns="91440" tIns="45720" rIns="91440" bIns="45720" numCol="1" spcCol="0" rtlCol="0" fromWordArt="0" anchor="t" anchorCtr="0" forceAA="0" compatLnSpc="1">
+            <a:prstTxWarp prst="textNoShape">
+              <a:avLst/>
+            </a:prstTxWarp>
+            <a:spAutoFit/>
+          </a:bodyPr>
+          <a:lstStyle/>
+          <a:p>
+            <a:pPr algn="l"/>
+            <a:r>
+              <a:rPr lang="es-ES" b="1">
+                <a:ea typeface="Calibri"/>
+                <a:cs typeface="Calibri"/>
+              </a:rPr>
+              <a:t>Deep</a:t>
+            </a:r>
+            <a:endParaRPr lang="es-ES">
+              <a:ea typeface="Calibri"/>
+              <a:cs typeface="Calibri"/>
+            </a:endParaRPr>
+          </a:p>
+        </p:txBody>
+      </p:sp>
+      <p:sp>
+        <p:nvSpPr>
+          <p:cNvPr id="10" name="CuadroTexto 9">
+            <a:extLst>
+              <a:ext uri="{FF2B5EF4-FFF2-40B4-BE49-F238E27FC236}">
+                <a16:creationId xmlns:a16="http://schemas.microsoft.com/office/drawing/2014/main" id="{3B6D20EB-E864-F0A4-E0FC-691B6FBB6953}"/>
+              </a:ext>
+            </a:extLst>
+          </p:cNvPr>
+          <p:cNvSpPr txBox="1"/>
+          <p:nvPr/>
+        </p:nvSpPr>
+        <p:spPr>
+          <a:xfrm>
+            <a:off x="1179619" y="3544609"/>
+            <a:ext cx="1393573" cy="369332"/>
+          </a:xfrm>
+          <a:prstGeom prst="rect">
+            <a:avLst/>
+          </a:prstGeom>
+          <a:noFill/>
+        </p:spPr>
+        <p:txBody>
+          <a:bodyPr rot="0" spcFirstLastPara="0" vertOverflow="overflow" horzOverflow="overflow" vert="horz" wrap="square" lIns="91440" tIns="45720" rIns="91440" bIns="45720" numCol="1" spcCol="0" rtlCol="0" fromWordArt="0" anchor="t" anchorCtr="0" forceAA="0" compatLnSpc="1">
+            <a:prstTxWarp prst="textNoShape">
+              <a:avLst/>
+            </a:prstTxWarp>
+            <a:spAutoFit/>
+          </a:bodyPr>
+          <a:lstStyle/>
+          <a:p>
+            <a:pPr algn="l"/>
+            <a:r>
+              <a:rPr lang="es-ES" b="1" dirty="0" err="1">
+                <a:ea typeface="Calibri"/>
+                <a:cs typeface="Calibri"/>
+              </a:rPr>
+              <a:t>Shallow</a:t>
+            </a:r>
+            <a:endParaRPr lang="es-ES" b="1" dirty="0" err="1"/>
           </a:p>
         </p:txBody>
       </p:sp>
@@ -20524,7 +21985,7 @@
                 <a:ea typeface="+mn-lt"/>
                 <a:cs typeface="+mn-lt"/>
               </a:rPr>
-              <a:t> (de ~30 µm a ~580 µm), </a:t>
+              <a:t> (de ~20 µm a ~330 µm), </a:t>
             </a:r>
             <a:r>
               <a:rPr lang="en-US" sz="1200" dirty="0" err="1">
@@ -20705,7 +22166,7 @@
       </p:pic>
       <p:pic>
         <p:nvPicPr>
-          <p:cNvPr id="5" name="Imagen 4" descr="Gráfico, Gráfico de líneas&#10;&#10;El contenido generado por IA puede ser incorrecto.">
+          <p:cNvPr id="5" name="Imagen 4">
             <a:extLst>
               <a:ext uri="{FF2B5EF4-FFF2-40B4-BE49-F238E27FC236}">
                 <a16:creationId xmlns:a16="http://schemas.microsoft.com/office/drawing/2014/main" id="{2E4BC672-E73E-1314-8E3F-C73A76F0B1FE}"/>
@@ -20725,8 +22186,8 @@
         </p:blipFill>
         <p:spPr>
           <a:xfrm>
-            <a:off x="6816899" y="1451800"/>
-            <a:ext cx="4161147" cy="3237221"/>
+            <a:off x="6837950" y="1451800"/>
+            <a:ext cx="4119045" cy="3237221"/>
           </a:xfrm>
           <a:prstGeom prst="rect">
             <a:avLst/>
@@ -21660,15 +23121,6 @@
 </file>
 
 <file path=customXml/item1.xml><?xml version="1.0" encoding="utf-8"?>
-<?mso-contentType ?>
-<FormTemplates xmlns="http://schemas.microsoft.com/sharepoint/v3/contenttype/forms">
-  <Display>DocumentLibraryForm</Display>
-  <Edit>DocumentLibraryForm</Edit>
-  <New>DocumentLibraryForm</New>
-</FormTemplates>
-</file>
-
-<file path=customXml/item2.xml><?xml version="1.0" encoding="utf-8"?>
 <ct:contentTypeSchema xmlns:ct="http://schemas.microsoft.com/office/2006/metadata/contentType" xmlns:ma="http://schemas.microsoft.com/office/2006/metadata/properties/metaAttributes" ct:_="" ma:_="" ma:contentTypeName="Documento" ma:contentTypeID="0x010100315676089F187543AA99C0A8B7AABBF0" ma:contentTypeVersion="3" ma:contentTypeDescription="Crear nuevo documento." ma:contentTypeScope="" ma:versionID="6b93a700db2c669d7bf6fe695110710d">
   <xsd:schema xmlns:xsd="http://www.w3.org/2001/XMLSchema" xmlns:xs="http://www.w3.org/2001/XMLSchema" xmlns:p="http://schemas.microsoft.com/office/2006/metadata/properties" xmlns:ns2="9e2adbf5-1345-474f-a313-aad13b917699" targetNamespace="http://schemas.microsoft.com/office/2006/metadata/properties" ma:root="true" ma:fieldsID="55ce8b8f8ed3bbb9007cedc7cfd21244" ns2:_="">
     <xsd:import namespace="9e2adbf5-1345-474f-a313-aad13b917699"/>
@@ -21806,6 +23258,15 @@
 </ct:contentTypeSchema>
 </file>
 
+<file path=customXml/item2.xml><?xml version="1.0" encoding="utf-8"?>
+<?mso-contentType ?>
+<FormTemplates xmlns="http://schemas.microsoft.com/sharepoint/v3/contenttype/forms">
+  <Display>DocumentLibraryForm</Display>
+  <Edit>DocumentLibraryForm</Edit>
+  <New>DocumentLibraryForm</New>
+</FormTemplates>
+</file>
+
 <file path=customXml/item3.xml><?xml version="1.0" encoding="utf-8"?>
 <p:properties xmlns:p="http://schemas.microsoft.com/office/2006/metadata/properties" xmlns:xsi="http://www.w3.org/2001/XMLSchema-instance" xmlns:pc="http://schemas.microsoft.com/office/infopath/2007/PartnerControls">
   <documentManagement/>
@@ -21813,14 +23274,6 @@
 </file>
 
 <file path=customXml/itemProps1.xml><?xml version="1.0" encoding="utf-8"?>
-<ds:datastoreItem xmlns:ds="http://schemas.openxmlformats.org/officeDocument/2006/customXml" ds:itemID="{A4C01FF3-9057-4EE0-AF52-564B32419BBE}">
-  <ds:schemaRefs>
-    <ds:schemaRef ds:uri="http://schemas.microsoft.com/sharepoint/v3/contenttype/forms"/>
-  </ds:schemaRefs>
-</ds:datastoreItem>
-</file>
-
-<file path=customXml/itemProps2.xml><?xml version="1.0" encoding="utf-8"?>
 <ds:datastoreItem xmlns:ds="http://schemas.openxmlformats.org/officeDocument/2006/customXml" ds:itemID="{AFE45E39-5DB8-4A83-9EAE-509B9DCEDD1B}">
   <ds:schemaRefs>
     <ds:schemaRef ds:uri="http://schemas.microsoft.com/office/2006/metadata/contentType"/>
@@ -21838,6 +23291,14 @@
 </ds:datastoreItem>
 </file>
 
+<file path=customXml/itemProps2.xml><?xml version="1.0" encoding="utf-8"?>
+<ds:datastoreItem xmlns:ds="http://schemas.openxmlformats.org/officeDocument/2006/customXml" ds:itemID="{A4C01FF3-9057-4EE0-AF52-564B32419BBE}">
+  <ds:schemaRefs>
+    <ds:schemaRef ds:uri="http://schemas.microsoft.com/sharepoint/v3/contenttype/forms"/>
+  </ds:schemaRefs>
+</ds:datastoreItem>
+</file>
+
 <file path=customXml/itemProps3.xml><?xml version="1.0" encoding="utf-8"?>
 <ds:datastoreItem xmlns:ds="http://schemas.openxmlformats.org/officeDocument/2006/customXml" ds:itemID="{E2653D22-1F8F-4A9E-A01A-CDB672760849}">
   <ds:schemaRefs>

</xml_diff>